<commit_message>
style(pitch): update deck branding to match accounted.se light paper and editorial typography
</commit_message>
<xml_diff>
--- a/public/docs/accounted_network_pitch_deck.pptx
+++ b/public/docs/accounted_network_pitch_deck.pptx
@@ -3118,7 +3118,7 @@
             <a:avLst/>
           </a:prstGeom>
           <a:solidFill>
-            <a:srgbClr val="0B0F19"/>
+            <a:srgbClr val="FAF8F5"/>
           </a:solidFill>
           <a:ln>
             <a:noFill/>
@@ -3154,18 +3154,18 @@
         </p:nvSpPr>
         <p:spPr>
           <a:xfrm>
-            <a:off x="4114800" y="914400"/>
+            <a:off x="4114800" y="822960"/>
             <a:ext cx="3962095" cy="411480"/>
           </a:xfrm>
           <a:prstGeom prst="roundRect">
             <a:avLst/>
           </a:prstGeom>
           <a:solidFill>
-            <a:srgbClr val="102C28"/>
+            <a:srgbClr val="F1F7F3"/>
           </a:solidFill>
           <a:ln w="12700">
             <a:solidFill>
-              <a:srgbClr val="10B981"/>
+              <a:srgbClr val="225E42"/>
             </a:solidFill>
           </a:ln>
         </p:spPr>
@@ -3190,13 +3190,13 @@
             <a:pPr algn="ctr">
               <a:defRPr sz="1000" b="1">
                 <a:solidFill>
-                  <a:srgbClr val="10B981"/>
-                </a:solidFill>
-                <a:latin typeface="Helvetica"/>
-              </a:defRPr>
-            </a:pPr>
-            <a:r>
-              <a:t>THE GLOBAL B2B SETTLEMENT PROTOCOL</a:t>
+                  <a:srgbClr val="225E42"/>
+                </a:solidFill>
+                <a:latin typeface="Helvetica"/>
+              </a:defRPr>
+            </a:pPr>
+            <a:r>
+              <a:t>accounted. — B2B SETTLEMENT NETWORK</a:t>
             </a:r>
           </a:p>
         </p:txBody>
@@ -3209,8 +3209,8 @@
         </p:nvSpPr>
         <p:spPr>
           <a:xfrm>
-            <a:off x="914400" y="1645920"/>
-            <a:ext cx="10362895" cy="1828800"/>
+            <a:off x="914400" y="1554480"/>
+            <a:ext cx="10362895" cy="2011680"/>
           </a:xfrm>
           <a:prstGeom prst="rect">
             <a:avLst/>
@@ -3226,9 +3226,9 @@
             <a:pPr algn="ctr">
               <a:defRPr sz="4000" b="1">
                 <a:solidFill>
-                  <a:srgbClr val="FFFFFF"/>
-                </a:solidFill>
-                <a:latin typeface="Helvetica"/>
+                  <a:srgbClr val="171717"/>
+                </a:solidFill>
+                <a:latin typeface="Georgia"/>
               </a:defRPr>
             </a:pPr>
             <a:r>
@@ -3237,9 +3237,9 @@
           </a:p>
           <a:p>
             <a:pPr algn="ctr">
-              <a:defRPr sz="1500">
-                <a:solidFill>
-                  <a:srgbClr val="94A3B8"/>
+              <a:defRPr sz="1400">
+                <a:solidFill>
+                  <a:srgbClr val="66625C"/>
                 </a:solidFill>
                 <a:latin typeface="Helvetica"/>
               </a:defRPr>
@@ -3263,17 +3263,17 @@
         <p:spPr>
           <a:xfrm>
             <a:off x="914400" y="3840480"/>
-            <a:ext cx="3200400" cy="2011680"/>
+            <a:ext cx="3200400" cy="2103120"/>
           </a:xfrm>
           <a:prstGeom prst="roundRect">
             <a:avLst/>
           </a:prstGeom>
           <a:solidFill>
-            <a:srgbClr val="131C2E"/>
+            <a:srgbClr val="FFFFFF"/>
           </a:solidFill>
           <a:ln w="12700">
             <a:solidFill>
-              <a:srgbClr val="1E293B"/>
+              <a:srgbClr val="E4E0D8"/>
             </a:solidFill>
           </a:ln>
         </p:spPr>
@@ -3298,8 +3298,9 @@
             <a:pPr algn="ctr">
               <a:defRPr sz="1000" b="1">
                 <a:solidFill>
-                  <a:srgbClr val="94A3B8"/>
-                </a:solidFill>
+                  <a:srgbClr val="66625C"/>
+                </a:solidFill>
+                <a:latin typeface="Helvetica"/>
               </a:defRPr>
             </a:pPr>
             <a:r>
@@ -3311,8 +3312,9 @@
             <a:pPr>
               <a:defRPr sz="2800" b="1">
                 <a:solidFill>
-                  <a:srgbClr val="FFFFFF"/>
-                </a:solidFill>
+                  <a:srgbClr val="171717"/>
+                </a:solidFill>
+                <a:latin typeface="Georgia"/>
               </a:defRPr>
             </a:pPr>
             <a:r>
@@ -3324,8 +3326,9 @@
             <a:pPr>
               <a:defRPr sz="1100">
                 <a:solidFill>
-                  <a:srgbClr val="94A3B8"/>
-                </a:solidFill>
+                  <a:srgbClr val="66625C"/>
+                </a:solidFill>
+                <a:latin typeface="Helvetica"/>
               </a:defRPr>
             </a:pPr>
             <a:r>
@@ -3343,17 +3346,17 @@
         <p:spPr>
           <a:xfrm>
             <a:off x="4480560" y="3840480"/>
-            <a:ext cx="3200400" cy="2011680"/>
+            <a:ext cx="3200400" cy="2103120"/>
           </a:xfrm>
           <a:prstGeom prst="roundRect">
             <a:avLst/>
           </a:prstGeom>
           <a:solidFill>
-            <a:srgbClr val="131C2E"/>
+            <a:srgbClr val="FFFFFF"/>
           </a:solidFill>
           <a:ln w="12700">
             <a:solidFill>
-              <a:srgbClr val="10B981"/>
+              <a:srgbClr val="225E42"/>
             </a:solidFill>
           </a:ln>
         </p:spPr>
@@ -3378,8 +3381,9 @@
             <a:pPr algn="ctr">
               <a:defRPr sz="1000" b="1">
                 <a:solidFill>
-                  <a:srgbClr val="10B981"/>
-                </a:solidFill>
+                  <a:srgbClr val="225E42"/>
+                </a:solidFill>
+                <a:latin typeface="Helvetica"/>
               </a:defRPr>
             </a:pPr>
             <a:r>
@@ -3391,8 +3395,9 @@
             <a:pPr>
               <a:defRPr sz="2800" b="1">
                 <a:solidFill>
-                  <a:srgbClr val="10B981"/>
-                </a:solidFill>
+                  <a:srgbClr val="225E42"/>
+                </a:solidFill>
+                <a:latin typeface="Georgia"/>
               </a:defRPr>
             </a:pPr>
             <a:r>
@@ -3404,8 +3409,9 @@
             <a:pPr>
               <a:defRPr sz="1100">
                 <a:solidFill>
-                  <a:srgbClr val="94A3B8"/>
-                </a:solidFill>
+                  <a:srgbClr val="66625C"/>
+                </a:solidFill>
+                <a:latin typeface="Helvetica"/>
               </a:defRPr>
             </a:pPr>
             <a:r>
@@ -3423,17 +3429,17 @@
         <p:spPr>
           <a:xfrm>
             <a:off x="8046720" y="3840480"/>
-            <a:ext cx="3200400" cy="2011680"/>
+            <a:ext cx="3200400" cy="2103120"/>
           </a:xfrm>
           <a:prstGeom prst="roundRect">
             <a:avLst/>
           </a:prstGeom>
           <a:solidFill>
-            <a:srgbClr val="131C2E"/>
+            <a:srgbClr val="FFFFFF"/>
           </a:solidFill>
           <a:ln w="12700">
             <a:solidFill>
-              <a:srgbClr val="14B8A6"/>
+              <a:srgbClr val="A65A24"/>
             </a:solidFill>
           </a:ln>
         </p:spPr>
@@ -3458,8 +3464,9 @@
             <a:pPr algn="ctr">
               <a:defRPr sz="1000" b="1">
                 <a:solidFill>
-                  <a:srgbClr val="14B8A6"/>
-                </a:solidFill>
+                  <a:srgbClr val="A65A24"/>
+                </a:solidFill>
+                <a:latin typeface="Helvetica"/>
               </a:defRPr>
             </a:pPr>
             <a:r>
@@ -3471,8 +3478,9 @@
             <a:pPr>
               <a:defRPr sz="2800" b="1">
                 <a:solidFill>
-                  <a:srgbClr val="14B8A6"/>
-                </a:solidFill>
+                  <a:srgbClr val="A65A24"/>
+                </a:solidFill>
+                <a:latin typeface="Georgia"/>
               </a:defRPr>
             </a:pPr>
             <a:r>
@@ -3484,8 +3492,9 @@
             <a:pPr>
               <a:defRPr sz="1100">
                 <a:solidFill>
-                  <a:srgbClr val="94A3B8"/>
-                </a:solidFill>
+                  <a:srgbClr val="66625C"/>
+                </a:solidFill>
+                <a:latin typeface="Helvetica"/>
               </a:defRPr>
             </a:pPr>
             <a:r>
@@ -3527,7 +3536,7 @@
             <a:avLst/>
           </a:prstGeom>
           <a:solidFill>
-            <a:srgbClr val="0B0F19"/>
+            <a:srgbClr val="FAF8F5"/>
           </a:solidFill>
           <a:ln>
             <a:noFill/>
@@ -3564,7 +3573,7 @@
         <p:spPr>
           <a:xfrm>
             <a:off x="731520" y="365760"/>
-            <a:ext cx="10698480" cy="365760"/>
+            <a:ext cx="10698480" cy="320040"/>
           </a:xfrm>
           <a:prstGeom prst="rect">
             <a:avLst/>
@@ -3580,7 +3589,7 @@
             <a:pPr>
               <a:defRPr sz="1000" b="1">
                 <a:solidFill>
-                  <a:srgbClr val="10B981"/>
+                  <a:srgbClr val="225E42"/>
                 </a:solidFill>
                 <a:latin typeface="Helvetica"/>
               </a:defRPr>
@@ -3616,9 +3625,9 @@
             <a:pPr>
               <a:defRPr sz="2400" b="1">
                 <a:solidFill>
-                  <a:srgbClr val="FFFFFF"/>
-                </a:solidFill>
-                <a:latin typeface="Helvetica"/>
+                  <a:srgbClr val="171717"/>
+                </a:solidFill>
+                <a:latin typeface="Georgia"/>
               </a:defRPr>
             </a:pPr>
             <a:r>
@@ -3627,9 +3636,9 @@
           </a:p>
           <a:p>
             <a:pPr>
-              <a:defRPr sz="1300">
-                <a:solidFill>
-                  <a:srgbClr val="94A3B8"/>
+              <a:defRPr sz="1200">
+                <a:solidFill>
+                  <a:srgbClr val="66625C"/>
                 </a:solidFill>
                 <a:latin typeface="Helvetica"/>
               </a:defRPr>
@@ -3655,11 +3664,11 @@
             <a:avLst/>
           </a:prstGeom>
           <a:solidFill>
-            <a:srgbClr val="131C2E"/>
+            <a:srgbClr val="FFFFFF"/>
           </a:solidFill>
           <a:ln w="12700">
             <a:solidFill>
-              <a:srgbClr val="1E293B"/>
+              <a:srgbClr val="E4E0D8"/>
             </a:solidFill>
           </a:ln>
         </p:spPr>
@@ -3682,10 +3691,11 @@
           <a:lstStyle/>
           <a:p>
             <a:pPr algn="ctr">
-              <a:defRPr sz="1300" b="1">
-                <a:solidFill>
-                  <a:srgbClr val="10B981"/>
-                </a:solidFill>
+              <a:defRPr sz="1200" b="1">
+                <a:solidFill>
+                  <a:srgbClr val="225E42"/>
+                </a:solidFill>
+                <a:latin typeface="Helvetica"/>
               </a:defRPr>
             </a:pPr>
             <a:r>
@@ -3697,8 +3707,9 @@
             <a:pPr>
               <a:defRPr sz="1050">
                 <a:solidFill>
-                  <a:srgbClr val="94A3B8"/>
-                </a:solidFill>
+                  <a:srgbClr val="66625C"/>
+                </a:solidFill>
+                <a:latin typeface="Helvetica"/>
               </a:defRPr>
             </a:pPr>
             <a:r>
@@ -3722,11 +3733,11 @@
             <a:avLst/>
           </a:prstGeom>
           <a:solidFill>
-            <a:srgbClr val="131C2E"/>
+            <a:srgbClr val="FFFFFF"/>
           </a:solidFill>
           <a:ln w="12700">
             <a:solidFill>
-              <a:srgbClr val="1E293B"/>
+              <a:srgbClr val="E4E0D8"/>
             </a:solidFill>
           </a:ln>
         </p:spPr>
@@ -3749,10 +3760,11 @@
           <a:lstStyle/>
           <a:p>
             <a:pPr algn="ctr">
-              <a:defRPr sz="1300" b="1">
-                <a:solidFill>
-                  <a:srgbClr val="10B981"/>
-                </a:solidFill>
+              <a:defRPr sz="1200" b="1">
+                <a:solidFill>
+                  <a:srgbClr val="225E42"/>
+                </a:solidFill>
+                <a:latin typeface="Helvetica"/>
               </a:defRPr>
             </a:pPr>
             <a:r>
@@ -3764,8 +3776,9 @@
             <a:pPr>
               <a:defRPr sz="1050">
                 <a:solidFill>
-                  <a:srgbClr val="94A3B8"/>
-                </a:solidFill>
+                  <a:srgbClr val="66625C"/>
+                </a:solidFill>
+                <a:latin typeface="Helvetica"/>
               </a:defRPr>
             </a:pPr>
             <a:r>
@@ -3789,11 +3802,11 @@
             <a:avLst/>
           </a:prstGeom>
           <a:solidFill>
-            <a:srgbClr val="131C2E"/>
+            <a:srgbClr val="FFFFFF"/>
           </a:solidFill>
           <a:ln w="12700">
             <a:solidFill>
-              <a:srgbClr val="1E293B"/>
+              <a:srgbClr val="E4E0D8"/>
             </a:solidFill>
           </a:ln>
         </p:spPr>
@@ -3816,10 +3829,11 @@
           <a:lstStyle/>
           <a:p>
             <a:pPr algn="ctr">
-              <a:defRPr sz="1300" b="1">
-                <a:solidFill>
-                  <a:srgbClr val="10B981"/>
-                </a:solidFill>
+              <a:defRPr sz="1200" b="1">
+                <a:solidFill>
+                  <a:srgbClr val="225E42"/>
+                </a:solidFill>
+                <a:latin typeface="Helvetica"/>
               </a:defRPr>
             </a:pPr>
             <a:r>
@@ -3831,8 +3845,9 @@
             <a:pPr>
               <a:defRPr sz="1050">
                 <a:solidFill>
-                  <a:srgbClr val="94A3B8"/>
-                </a:solidFill>
+                  <a:srgbClr val="66625C"/>
+                </a:solidFill>
+                <a:latin typeface="Helvetica"/>
               </a:defRPr>
             </a:pPr>
             <a:r>
@@ -3856,11 +3871,11 @@
             <a:avLst/>
           </a:prstGeom>
           <a:solidFill>
-            <a:srgbClr val="131C2E"/>
+            <a:srgbClr val="FFFFFF"/>
           </a:solidFill>
           <a:ln w="12700">
             <a:solidFill>
-              <a:srgbClr val="1E293B"/>
+              <a:srgbClr val="E4E0D8"/>
             </a:solidFill>
           </a:ln>
         </p:spPr>
@@ -3883,10 +3898,11 @@
           <a:lstStyle/>
           <a:p>
             <a:pPr algn="ctr">
-              <a:defRPr sz="1300" b="1">
-                <a:solidFill>
-                  <a:srgbClr val="10B981"/>
-                </a:solidFill>
+              <a:defRPr sz="1200" b="1">
+                <a:solidFill>
+                  <a:srgbClr val="225E42"/>
+                </a:solidFill>
+                <a:latin typeface="Helvetica"/>
               </a:defRPr>
             </a:pPr>
             <a:r>
@@ -3898,8 +3914,9 @@
             <a:pPr>
               <a:defRPr sz="1050">
                 <a:solidFill>
-                  <a:srgbClr val="94A3B8"/>
-                </a:solidFill>
+                  <a:srgbClr val="66625C"/>
+                </a:solidFill>
+                <a:latin typeface="Helvetica"/>
               </a:defRPr>
             </a:pPr>
             <a:r>
@@ -3923,11 +3940,11 @@
             <a:avLst/>
           </a:prstGeom>
           <a:solidFill>
-            <a:srgbClr val="131C2E"/>
+            <a:srgbClr val="F3F0EA"/>
           </a:solidFill>
           <a:ln w="12700">
             <a:solidFill>
-              <a:srgbClr val="1E293B"/>
+              <a:srgbClr val="E4E0D8"/>
             </a:solidFill>
           </a:ln>
         </p:spPr>
@@ -3950,10 +3967,11 @@
           <a:lstStyle/>
           <a:p>
             <a:pPr algn="ctr">
-              <a:defRPr sz="1200" b="1">
-                <a:solidFill>
-                  <a:srgbClr val="FFFFFF"/>
-                </a:solidFill>
+              <a:defRPr sz="1150" b="1">
+                <a:solidFill>
+                  <a:srgbClr val="171717"/>
+                </a:solidFill>
+                <a:latin typeface="Helvetica"/>
               </a:defRPr>
             </a:pPr>
             <a:r>
@@ -3995,7 +4013,7 @@
             <a:avLst/>
           </a:prstGeom>
           <a:solidFill>
-            <a:srgbClr val="0B0F19"/>
+            <a:srgbClr val="FAF8F5"/>
           </a:solidFill>
           <a:ln>
             <a:noFill/>
@@ -4032,7 +4050,7 @@
         <p:spPr>
           <a:xfrm>
             <a:off x="731520" y="365760"/>
-            <a:ext cx="10698480" cy="365760"/>
+            <a:ext cx="10698480" cy="320040"/>
           </a:xfrm>
           <a:prstGeom prst="rect">
             <a:avLst/>
@@ -4048,7 +4066,7 @@
             <a:pPr>
               <a:defRPr sz="1000" b="1">
                 <a:solidFill>
-                  <a:srgbClr val="10B981"/>
+                  <a:srgbClr val="225E42"/>
                 </a:solidFill>
                 <a:latin typeface="Helvetica"/>
               </a:defRPr>
@@ -4084,9 +4102,9 @@
             <a:pPr>
               <a:defRPr sz="2400" b="1">
                 <a:solidFill>
-                  <a:srgbClr val="FFFFFF"/>
-                </a:solidFill>
-                <a:latin typeface="Helvetica"/>
+                  <a:srgbClr val="171717"/>
+                </a:solidFill>
+                <a:latin typeface="Georgia"/>
               </a:defRPr>
             </a:pPr>
             <a:r>
@@ -4095,9 +4113,9 @@
           </a:p>
           <a:p>
             <a:pPr>
-              <a:defRPr sz="1300">
-                <a:solidFill>
-                  <a:srgbClr val="94A3B8"/>
+              <a:defRPr sz="1200">
+                <a:solidFill>
+                  <a:srgbClr val="66625C"/>
                 </a:solidFill>
                 <a:latin typeface="Helvetica"/>
               </a:defRPr>
@@ -4123,11 +4141,11 @@
             <a:avLst/>
           </a:prstGeom>
           <a:solidFill>
-            <a:srgbClr val="131C2E"/>
+            <a:srgbClr val="FFFFFF"/>
           </a:solidFill>
           <a:ln w="12700">
             <a:solidFill>
-              <a:srgbClr val="10B981"/>
+              <a:srgbClr val="225E42"/>
             </a:solidFill>
           </a:ln>
         </p:spPr>
@@ -4152,8 +4170,9 @@
             <a:pPr algn="ctr">
               <a:defRPr sz="1100" b="1">
                 <a:solidFill>
-                  <a:srgbClr val="10B981"/>
-                </a:solidFill>
+                  <a:srgbClr val="225E42"/>
+                </a:solidFill>
+                <a:latin typeface="Helvetica"/>
               </a:defRPr>
             </a:pPr>
             <a:r>
@@ -4165,8 +4184,9 @@
             <a:pPr>
               <a:defRPr sz="1600" b="1">
                 <a:solidFill>
-                  <a:srgbClr val="FFFFFF"/>
-                </a:solidFill>
+                  <a:srgbClr val="171717"/>
+                </a:solidFill>
+                <a:latin typeface="Georgia"/>
               </a:defRPr>
             </a:pPr>
             <a:r>
@@ -4179,8 +4199,9 @@
             <a:pPr>
               <a:defRPr sz="1100">
                 <a:solidFill>
-                  <a:srgbClr val="94A3B8"/>
-                </a:solidFill>
+                  <a:srgbClr val="66625C"/>
+                </a:solidFill>
+                <a:latin typeface="Helvetica"/>
               </a:defRPr>
             </a:pPr>
             <a:r>
@@ -4204,11 +4225,11 @@
             <a:avLst/>
           </a:prstGeom>
           <a:solidFill>
-            <a:srgbClr val="131C2E"/>
+            <a:srgbClr val="FFFFFF"/>
           </a:solidFill>
           <a:ln w="12700">
             <a:solidFill>
-              <a:srgbClr val="14B8A6"/>
+              <a:srgbClr val="A65A24"/>
             </a:solidFill>
           </a:ln>
         </p:spPr>
@@ -4233,8 +4254,9 @@
             <a:pPr algn="ctr">
               <a:defRPr sz="1100" b="1">
                 <a:solidFill>
-                  <a:srgbClr val="14B8A6"/>
-                </a:solidFill>
+                  <a:srgbClr val="A65A24"/>
+                </a:solidFill>
+                <a:latin typeface="Helvetica"/>
               </a:defRPr>
             </a:pPr>
             <a:r>
@@ -4246,8 +4268,9 @@
             <a:pPr>
               <a:defRPr sz="1600" b="1">
                 <a:solidFill>
-                  <a:srgbClr val="FFFFFF"/>
-                </a:solidFill>
+                  <a:srgbClr val="171717"/>
+                </a:solidFill>
+                <a:latin typeface="Georgia"/>
               </a:defRPr>
             </a:pPr>
             <a:r>
@@ -4260,8 +4283,9 @@
             <a:pPr>
               <a:defRPr sz="1100">
                 <a:solidFill>
-                  <a:srgbClr val="94A3B8"/>
-                </a:solidFill>
+                  <a:srgbClr val="66625C"/>
+                </a:solidFill>
+                <a:latin typeface="Helvetica"/>
               </a:defRPr>
             </a:pPr>
             <a:r>
@@ -4285,11 +4309,11 @@
             <a:avLst/>
           </a:prstGeom>
           <a:solidFill>
-            <a:srgbClr val="131C2E"/>
+            <a:srgbClr val="FFFFFF"/>
           </a:solidFill>
           <a:ln w="12700">
             <a:solidFill>
-              <a:srgbClr val="06B6D4"/>
+              <a:srgbClr val="171717"/>
             </a:solidFill>
           </a:ln>
         </p:spPr>
@@ -4314,8 +4338,9 @@
             <a:pPr algn="ctr">
               <a:defRPr sz="1100" b="1">
                 <a:solidFill>
-                  <a:srgbClr val="06B6D4"/>
-                </a:solidFill>
+                  <a:srgbClr val="171717"/>
+                </a:solidFill>
+                <a:latin typeface="Helvetica"/>
               </a:defRPr>
             </a:pPr>
             <a:r>
@@ -4327,8 +4352,9 @@
             <a:pPr>
               <a:defRPr sz="1600" b="1">
                 <a:solidFill>
-                  <a:srgbClr val="FFFFFF"/>
-                </a:solidFill>
+                  <a:srgbClr val="171717"/>
+                </a:solidFill>
+                <a:latin typeface="Georgia"/>
               </a:defRPr>
             </a:pPr>
             <a:r>
@@ -4341,8 +4367,9 @@
             <a:pPr>
               <a:defRPr sz="1100">
                 <a:solidFill>
-                  <a:srgbClr val="94A3B8"/>
-                </a:solidFill>
+                  <a:srgbClr val="66625C"/>
+                </a:solidFill>
+                <a:latin typeface="Helvetica"/>
               </a:defRPr>
             </a:pPr>
             <a:r>
@@ -4366,11 +4393,11 @@
             <a:avLst/>
           </a:prstGeom>
           <a:solidFill>
-            <a:srgbClr val="131C2E"/>
+            <a:srgbClr val="F3F0EA"/>
           </a:solidFill>
           <a:ln w="12700">
             <a:solidFill>
-              <a:srgbClr val="1E293B"/>
+              <a:srgbClr val="E4E0D8"/>
             </a:solidFill>
           </a:ln>
         </p:spPr>
@@ -4395,8 +4422,9 @@
             <a:pPr algn="ctr">
               <a:defRPr sz="1100" b="1">
                 <a:solidFill>
-                  <a:srgbClr val="10B981"/>
-                </a:solidFill>
+                  <a:srgbClr val="225E42"/>
+                </a:solidFill>
+                <a:latin typeface="Helvetica"/>
               </a:defRPr>
             </a:pPr>
             <a:r>
@@ -4438,7 +4466,7 @@
             <a:avLst/>
           </a:prstGeom>
           <a:solidFill>
-            <a:srgbClr val="0B0F19"/>
+            <a:srgbClr val="FAF8F5"/>
           </a:solidFill>
           <a:ln>
             <a:noFill/>
@@ -4475,7 +4503,7 @@
         <p:spPr>
           <a:xfrm>
             <a:off x="731520" y="365760"/>
-            <a:ext cx="10698480" cy="365760"/>
+            <a:ext cx="10698480" cy="320040"/>
           </a:xfrm>
           <a:prstGeom prst="rect">
             <a:avLst/>
@@ -4491,7 +4519,7 @@
             <a:pPr>
               <a:defRPr sz="1000" b="1">
                 <a:solidFill>
-                  <a:srgbClr val="10B981"/>
+                  <a:srgbClr val="225E42"/>
                 </a:solidFill>
                 <a:latin typeface="Helvetica"/>
               </a:defRPr>
@@ -4527,9 +4555,9 @@
             <a:pPr>
               <a:defRPr sz="2400" b="1">
                 <a:solidFill>
-                  <a:srgbClr val="FFFFFF"/>
-                </a:solidFill>
-                <a:latin typeface="Helvetica"/>
+                  <a:srgbClr val="171717"/>
+                </a:solidFill>
+                <a:latin typeface="Georgia"/>
               </a:defRPr>
             </a:pPr>
             <a:r>
@@ -4538,9 +4566,9 @@
           </a:p>
           <a:p>
             <a:pPr>
-              <a:defRPr sz="1300">
-                <a:solidFill>
-                  <a:srgbClr val="94A3B8"/>
+              <a:defRPr sz="1200">
+                <a:solidFill>
+                  <a:srgbClr val="66625C"/>
                 </a:solidFill>
                 <a:latin typeface="Helvetica"/>
               </a:defRPr>
@@ -4566,11 +4594,11 @@
             <a:avLst/>
           </a:prstGeom>
           <a:solidFill>
-            <a:srgbClr val="131C2E"/>
+            <a:srgbClr val="FFFFFF"/>
           </a:solidFill>
           <a:ln w="12700">
             <a:solidFill>
-              <a:srgbClr val="1E293B"/>
+              <a:srgbClr val="E4E0D8"/>
             </a:solidFill>
           </a:ln>
         </p:spPr>
@@ -4595,8 +4623,9 @@
             <a:pPr algn="ctr">
               <a:defRPr sz="1100" b="1">
                 <a:solidFill>
-                  <a:srgbClr val="10B981"/>
-                </a:solidFill>
+                  <a:srgbClr val="225E42"/>
+                </a:solidFill>
+                <a:latin typeface="Helvetica"/>
               </a:defRPr>
             </a:pPr>
             <a:r>
@@ -4608,8 +4637,9 @@
             <a:pPr>
               <a:defRPr sz="1600" b="1">
                 <a:solidFill>
-                  <a:srgbClr val="FFFFFF"/>
-                </a:solidFill>
+                  <a:srgbClr val="171717"/>
+                </a:solidFill>
+                <a:latin typeface="Georgia"/>
               </a:defRPr>
             </a:pPr>
             <a:r>
@@ -4622,8 +4652,9 @@
             <a:pPr>
               <a:defRPr sz="1100">
                 <a:solidFill>
-                  <a:srgbClr val="94A3B8"/>
-                </a:solidFill>
+                  <a:srgbClr val="66625C"/>
+                </a:solidFill>
+                <a:latin typeface="Helvetica"/>
               </a:defRPr>
             </a:pPr>
             <a:r>
@@ -4634,8 +4665,9 @@
             <a:pPr>
               <a:defRPr sz="1100">
                 <a:solidFill>
-                  <a:srgbClr val="94A3B8"/>
-                </a:solidFill>
+                  <a:srgbClr val="66625C"/>
+                </a:solidFill>
+                <a:latin typeface="Helvetica"/>
               </a:defRPr>
             </a:pPr>
             <a:r>
@@ -4646,8 +4678,9 @@
             <a:pPr>
               <a:defRPr sz="1100">
                 <a:solidFill>
-                  <a:srgbClr val="94A3B8"/>
-                </a:solidFill>
+                  <a:srgbClr val="66625C"/>
+                </a:solidFill>
+                <a:latin typeface="Helvetica"/>
               </a:defRPr>
             </a:pPr>
             <a:r>
@@ -4658,8 +4691,9 @@
             <a:pPr>
               <a:defRPr sz="1100">
                 <a:solidFill>
-                  <a:srgbClr val="94A3B8"/>
-                </a:solidFill>
+                  <a:srgbClr val="66625C"/>
+                </a:solidFill>
+                <a:latin typeface="Helvetica"/>
               </a:defRPr>
             </a:pPr>
             <a:r>
@@ -4671,8 +4705,9 @@
             <a:pPr>
               <a:defRPr sz="1100" b="1">
                 <a:solidFill>
-                  <a:srgbClr val="10B981"/>
-                </a:solidFill>
+                  <a:srgbClr val="225E42"/>
+                </a:solidFill>
+                <a:latin typeface="Helvetica"/>
               </a:defRPr>
             </a:pPr>
             <a:r>
@@ -4696,11 +4731,11 @@
             <a:avLst/>
           </a:prstGeom>
           <a:solidFill>
-            <a:srgbClr val="131C2E"/>
+            <a:srgbClr val="FFFFFF"/>
           </a:solidFill>
           <a:ln w="12700">
             <a:solidFill>
-              <a:srgbClr val="1E293B"/>
+              <a:srgbClr val="E4E0D8"/>
             </a:solidFill>
           </a:ln>
         </p:spPr>
@@ -4725,8 +4760,9 @@
             <a:pPr algn="ctr">
               <a:defRPr sz="1100" b="1">
                 <a:solidFill>
-                  <a:srgbClr val="14B8A6"/>
-                </a:solidFill>
+                  <a:srgbClr val="A65A24"/>
+                </a:solidFill>
+                <a:latin typeface="Helvetica"/>
               </a:defRPr>
             </a:pPr>
             <a:r>
@@ -4738,8 +4774,9 @@
             <a:pPr>
               <a:defRPr sz="1600" b="1">
                 <a:solidFill>
-                  <a:srgbClr val="FFFFFF"/>
-                </a:solidFill>
+                  <a:srgbClr val="171717"/>
+                </a:solidFill>
+                <a:latin typeface="Georgia"/>
               </a:defRPr>
             </a:pPr>
             <a:r>
@@ -4752,8 +4789,9 @@
             <a:pPr>
               <a:defRPr sz="1100">
                 <a:solidFill>
-                  <a:srgbClr val="94A3B8"/>
-                </a:solidFill>
+                  <a:srgbClr val="66625C"/>
+                </a:solidFill>
+                <a:latin typeface="Helvetica"/>
               </a:defRPr>
             </a:pPr>
             <a:r>
@@ -4764,8 +4802,9 @@
             <a:pPr>
               <a:defRPr sz="1100">
                 <a:solidFill>
-                  <a:srgbClr val="94A3B8"/>
-                </a:solidFill>
+                  <a:srgbClr val="66625C"/>
+                </a:solidFill>
+                <a:latin typeface="Helvetica"/>
               </a:defRPr>
             </a:pPr>
             <a:r>
@@ -4776,8 +4815,9 @@
             <a:pPr>
               <a:defRPr sz="1100">
                 <a:solidFill>
-                  <a:srgbClr val="94A3B8"/>
-                </a:solidFill>
+                  <a:srgbClr val="66625C"/>
+                </a:solidFill>
+                <a:latin typeface="Helvetica"/>
               </a:defRPr>
             </a:pPr>
             <a:r>
@@ -4788,8 +4828,9 @@
             <a:pPr>
               <a:defRPr sz="1100">
                 <a:solidFill>
-                  <a:srgbClr val="94A3B8"/>
-                </a:solidFill>
+                  <a:srgbClr val="66625C"/>
+                </a:solidFill>
+                <a:latin typeface="Helvetica"/>
               </a:defRPr>
             </a:pPr>
             <a:r>
@@ -4801,8 +4842,9 @@
             <a:pPr>
               <a:defRPr sz="1100" b="1">
                 <a:solidFill>
-                  <a:srgbClr val="14B8A6"/>
-                </a:solidFill>
+                  <a:srgbClr val="A65A24"/>
+                </a:solidFill>
+                <a:latin typeface="Helvetica"/>
               </a:defRPr>
             </a:pPr>
             <a:r>
@@ -4826,11 +4868,11 @@
             <a:avLst/>
           </a:prstGeom>
           <a:solidFill>
-            <a:srgbClr val="131C2E"/>
+            <a:srgbClr val="FFFFFF"/>
           </a:solidFill>
           <a:ln w="12700">
             <a:solidFill>
-              <a:srgbClr val="1E293B"/>
+              <a:srgbClr val="E4E0D8"/>
             </a:solidFill>
           </a:ln>
         </p:spPr>
@@ -4855,8 +4897,9 @@
             <a:pPr algn="ctr">
               <a:defRPr sz="1100" b="1">
                 <a:solidFill>
-                  <a:srgbClr val="FFFFFF"/>
-                </a:solidFill>
+                  <a:srgbClr val="171717"/>
+                </a:solidFill>
+                <a:latin typeface="Helvetica"/>
               </a:defRPr>
             </a:pPr>
             <a:r>
@@ -4868,8 +4911,9 @@
             <a:pPr>
               <a:defRPr sz="1600" b="1">
                 <a:solidFill>
-                  <a:srgbClr val="FFFFFF"/>
-                </a:solidFill>
+                  <a:srgbClr val="171717"/>
+                </a:solidFill>
+                <a:latin typeface="Georgia"/>
               </a:defRPr>
             </a:pPr>
             <a:r>
@@ -4882,8 +4926,9 @@
             <a:pPr>
               <a:defRPr sz="1100">
                 <a:solidFill>
-                  <a:srgbClr val="94A3B8"/>
-                </a:solidFill>
+                  <a:srgbClr val="66625C"/>
+                </a:solidFill>
+                <a:latin typeface="Helvetica"/>
               </a:defRPr>
             </a:pPr>
             <a:r>
@@ -4894,8 +4939,9 @@
             <a:pPr>
               <a:defRPr sz="1100">
                 <a:solidFill>
-                  <a:srgbClr val="94A3B8"/>
-                </a:solidFill>
+                  <a:srgbClr val="66625C"/>
+                </a:solidFill>
+                <a:latin typeface="Helvetica"/>
               </a:defRPr>
             </a:pPr>
             <a:r>
@@ -4906,8 +4952,9 @@
             <a:pPr>
               <a:defRPr sz="1100">
                 <a:solidFill>
-                  <a:srgbClr val="94A3B8"/>
-                </a:solidFill>
+                  <a:srgbClr val="66625C"/>
+                </a:solidFill>
+                <a:latin typeface="Helvetica"/>
               </a:defRPr>
             </a:pPr>
             <a:r>
@@ -4918,8 +4965,9 @@
             <a:pPr>
               <a:defRPr sz="1100">
                 <a:solidFill>
-                  <a:srgbClr val="94A3B8"/>
-                </a:solidFill>
+                  <a:srgbClr val="66625C"/>
+                </a:solidFill>
+                <a:latin typeface="Helvetica"/>
               </a:defRPr>
             </a:pPr>
             <a:r>
@@ -4931,8 +4979,9 @@
             <a:pPr>
               <a:defRPr sz="1100" b="1">
                 <a:solidFill>
-                  <a:srgbClr val="FFFFFF"/>
-                </a:solidFill>
+                  <a:srgbClr val="171717"/>
+                </a:solidFill>
+                <a:latin typeface="Helvetica"/>
               </a:defRPr>
             </a:pPr>
             <a:r>
@@ -4956,11 +5005,11 @@
             <a:avLst/>
           </a:prstGeom>
           <a:solidFill>
-            <a:srgbClr val="131C2E"/>
+            <a:srgbClr val="F3F0EA"/>
           </a:solidFill>
           <a:ln w="12700">
             <a:solidFill>
-              <a:srgbClr val="1E293B"/>
+              <a:srgbClr val="E4E0D8"/>
             </a:solidFill>
           </a:ln>
         </p:spPr>
@@ -4985,8 +5034,9 @@
             <a:pPr algn="ctr">
               <a:defRPr sz="1100" b="1">
                 <a:solidFill>
-                  <a:srgbClr val="FFFFFF"/>
-                </a:solidFill>
+                  <a:srgbClr val="171717"/>
+                </a:solidFill>
+                <a:latin typeface="Helvetica"/>
               </a:defRPr>
             </a:pPr>
             <a:r>
@@ -5028,7 +5078,7 @@
             <a:avLst/>
           </a:prstGeom>
           <a:solidFill>
-            <a:srgbClr val="0B0F19"/>
+            <a:srgbClr val="FAF8F5"/>
           </a:solidFill>
           <a:ln>
             <a:noFill/>
@@ -5065,7 +5115,7 @@
         <p:spPr>
           <a:xfrm>
             <a:off x="731520" y="365760"/>
-            <a:ext cx="10698480" cy="365760"/>
+            <a:ext cx="10698480" cy="320040"/>
           </a:xfrm>
           <a:prstGeom prst="rect">
             <a:avLst/>
@@ -5081,7 +5131,7 @@
             <a:pPr>
               <a:defRPr sz="1000" b="1">
                 <a:solidFill>
-                  <a:srgbClr val="10B981"/>
+                  <a:srgbClr val="225E42"/>
                 </a:solidFill>
                 <a:latin typeface="Helvetica"/>
               </a:defRPr>
@@ -5117,9 +5167,9 @@
             <a:pPr>
               <a:defRPr sz="2400" b="1">
                 <a:solidFill>
-                  <a:srgbClr val="FFFFFF"/>
-                </a:solidFill>
-                <a:latin typeface="Helvetica"/>
+                  <a:srgbClr val="171717"/>
+                </a:solidFill>
+                <a:latin typeface="Georgia"/>
               </a:defRPr>
             </a:pPr>
             <a:r>
@@ -5128,9 +5178,9 @@
           </a:p>
           <a:p>
             <a:pPr>
-              <a:defRPr sz="1300">
-                <a:solidFill>
-                  <a:srgbClr val="94A3B8"/>
+              <a:defRPr sz="1200">
+                <a:solidFill>
+                  <a:srgbClr val="66625C"/>
                 </a:solidFill>
                 <a:latin typeface="Helvetica"/>
               </a:defRPr>
@@ -5156,11 +5206,11 @@
             <a:avLst/>
           </a:prstGeom>
           <a:solidFill>
-            <a:srgbClr val="131C2E"/>
+            <a:srgbClr val="FFFFFF"/>
           </a:solidFill>
           <a:ln w="12700">
             <a:solidFill>
-              <a:srgbClr val="1E293B"/>
+              <a:srgbClr val="E4E0D8"/>
             </a:solidFill>
           </a:ln>
         </p:spPr>
@@ -5185,8 +5235,9 @@
             <a:pPr algn="ctr">
               <a:defRPr sz="1000" b="1">
                 <a:solidFill>
-                  <a:srgbClr val="94A3B8"/>
-                </a:solidFill>
+                  <a:srgbClr val="66625C"/>
+                </a:solidFill>
+                <a:latin typeface="Helvetica"/>
               </a:defRPr>
             </a:pPr>
             <a:r>
@@ -5198,8 +5249,9 @@
             <a:pPr>
               <a:defRPr sz="2200" b="1">
                 <a:solidFill>
-                  <a:srgbClr val="10B981"/>
-                </a:solidFill>
+                  <a:srgbClr val="225E42"/>
+                </a:solidFill>
+                <a:latin typeface="Georgia"/>
               </a:defRPr>
             </a:pPr>
             <a:r>
@@ -5209,10 +5261,11 @@
           </a:p>
           <a:p>
             <a:pPr>
-              <a:defRPr sz="1300" b="1">
-                <a:solidFill>
-                  <a:srgbClr val="FFFFFF"/>
-                </a:solidFill>
+              <a:defRPr sz="1200" b="1">
+                <a:solidFill>
+                  <a:srgbClr val="171717"/>
+                </a:solidFill>
+                <a:latin typeface="Helvetica"/>
               </a:defRPr>
             </a:pPr>
             <a:r>
@@ -5225,8 +5278,9 @@
             <a:pPr>
               <a:defRPr sz="1000">
                 <a:solidFill>
-                  <a:srgbClr val="94A3B8"/>
-                </a:solidFill>
+                  <a:srgbClr val="66625C"/>
+                </a:solidFill>
+                <a:latin typeface="Helvetica"/>
               </a:defRPr>
             </a:pPr>
             <a:r>
@@ -5250,11 +5304,11 @@
             <a:avLst/>
           </a:prstGeom>
           <a:solidFill>
-            <a:srgbClr val="131C2E"/>
+            <a:srgbClr val="FFFFFF"/>
           </a:solidFill>
           <a:ln w="12700">
             <a:solidFill>
-              <a:srgbClr val="1E293B"/>
+              <a:srgbClr val="E4E0D8"/>
             </a:solidFill>
           </a:ln>
         </p:spPr>
@@ -5279,8 +5333,9 @@
             <a:pPr algn="ctr">
               <a:defRPr sz="1000" b="1">
                 <a:solidFill>
-                  <a:srgbClr val="94A3B8"/>
-                </a:solidFill>
+                  <a:srgbClr val="66625C"/>
+                </a:solidFill>
+                <a:latin typeface="Helvetica"/>
               </a:defRPr>
             </a:pPr>
             <a:r>
@@ -5292,8 +5347,9 @@
             <a:pPr>
               <a:defRPr sz="2200" b="1">
                 <a:solidFill>
-                  <a:srgbClr val="14B8A6"/>
-                </a:solidFill>
+                  <a:srgbClr val="171717"/>
+                </a:solidFill>
+                <a:latin typeface="Georgia"/>
               </a:defRPr>
             </a:pPr>
             <a:r>
@@ -5303,10 +5359,11 @@
           </a:p>
           <a:p>
             <a:pPr>
-              <a:defRPr sz="1300" b="1">
-                <a:solidFill>
-                  <a:srgbClr val="FFFFFF"/>
-                </a:solidFill>
+              <a:defRPr sz="1200" b="1">
+                <a:solidFill>
+                  <a:srgbClr val="171717"/>
+                </a:solidFill>
+                <a:latin typeface="Helvetica"/>
               </a:defRPr>
             </a:pPr>
             <a:r>
@@ -5319,8 +5376,9 @@
             <a:pPr>
               <a:defRPr sz="1000">
                 <a:solidFill>
-                  <a:srgbClr val="94A3B8"/>
-                </a:solidFill>
+                  <a:srgbClr val="66625C"/>
+                </a:solidFill>
+                <a:latin typeface="Helvetica"/>
               </a:defRPr>
             </a:pPr>
             <a:r>
@@ -5344,11 +5402,11 @@
             <a:avLst/>
           </a:prstGeom>
           <a:solidFill>
-            <a:srgbClr val="131C2E"/>
+            <a:srgbClr val="FFFFFF"/>
           </a:solidFill>
           <a:ln w="12700">
             <a:solidFill>
-              <a:srgbClr val="1E293B"/>
+              <a:srgbClr val="E4E0D8"/>
             </a:solidFill>
           </a:ln>
         </p:spPr>
@@ -5373,8 +5431,9 @@
             <a:pPr algn="ctr">
               <a:defRPr sz="1000" b="1">
                 <a:solidFill>
-                  <a:srgbClr val="94A3B8"/>
-                </a:solidFill>
+                  <a:srgbClr val="66625C"/>
+                </a:solidFill>
+                <a:latin typeface="Helvetica"/>
               </a:defRPr>
             </a:pPr>
             <a:r>
@@ -5386,8 +5445,9 @@
             <a:pPr>
               <a:defRPr sz="2200" b="1">
                 <a:solidFill>
-                  <a:srgbClr val="10B981"/>
-                </a:solidFill>
+                  <a:srgbClr val="225E42"/>
+                </a:solidFill>
+                <a:latin typeface="Georgia"/>
               </a:defRPr>
             </a:pPr>
             <a:r>
@@ -5397,10 +5457,11 @@
           </a:p>
           <a:p>
             <a:pPr>
-              <a:defRPr sz="1300" b="1">
-                <a:solidFill>
-                  <a:srgbClr val="FFFFFF"/>
-                </a:solidFill>
+              <a:defRPr sz="1200" b="1">
+                <a:solidFill>
+                  <a:srgbClr val="171717"/>
+                </a:solidFill>
+                <a:latin typeface="Helvetica"/>
               </a:defRPr>
             </a:pPr>
             <a:r>
@@ -5413,8 +5474,9 @@
             <a:pPr>
               <a:defRPr sz="1000">
                 <a:solidFill>
-                  <a:srgbClr val="94A3B8"/>
-                </a:solidFill>
+                  <a:srgbClr val="66625C"/>
+                </a:solidFill>
+                <a:latin typeface="Helvetica"/>
               </a:defRPr>
             </a:pPr>
             <a:r>
@@ -5438,11 +5500,11 @@
             <a:avLst/>
           </a:prstGeom>
           <a:solidFill>
-            <a:srgbClr val="131C2E"/>
+            <a:srgbClr val="FFFFFF"/>
           </a:solidFill>
           <a:ln w="12700">
             <a:solidFill>
-              <a:srgbClr val="1E293B"/>
+              <a:srgbClr val="E4E0D8"/>
             </a:solidFill>
           </a:ln>
         </p:spPr>
@@ -5467,8 +5529,9 @@
             <a:pPr algn="ctr">
               <a:defRPr sz="1000" b="1">
                 <a:solidFill>
-                  <a:srgbClr val="94A3B8"/>
-                </a:solidFill>
+                  <a:srgbClr val="66625C"/>
+                </a:solidFill>
+                <a:latin typeface="Helvetica"/>
               </a:defRPr>
             </a:pPr>
             <a:r>
@@ -5480,8 +5543,9 @@
             <a:pPr>
               <a:defRPr sz="2200" b="1">
                 <a:solidFill>
-                  <a:srgbClr val="06B6D4"/>
-                </a:solidFill>
+                  <a:srgbClr val="A65A24"/>
+                </a:solidFill>
+                <a:latin typeface="Georgia"/>
               </a:defRPr>
             </a:pPr>
             <a:r>
@@ -5491,10 +5555,11 @@
           </a:p>
           <a:p>
             <a:pPr>
-              <a:defRPr sz="1300" b="1">
-                <a:solidFill>
-                  <a:srgbClr val="FFFFFF"/>
-                </a:solidFill>
+              <a:defRPr sz="1200" b="1">
+                <a:solidFill>
+                  <a:srgbClr val="171717"/>
+                </a:solidFill>
+                <a:latin typeface="Helvetica"/>
               </a:defRPr>
             </a:pPr>
             <a:r>
@@ -5507,8 +5572,9 @@
             <a:pPr>
               <a:defRPr sz="1000">
                 <a:solidFill>
-                  <a:srgbClr val="94A3B8"/>
-                </a:solidFill>
+                  <a:srgbClr val="66625C"/>
+                </a:solidFill>
+                <a:latin typeface="Helvetica"/>
               </a:defRPr>
             </a:pPr>
             <a:r>
@@ -5532,11 +5598,11 @@
             <a:avLst/>
           </a:prstGeom>
           <a:solidFill>
-            <a:srgbClr val="131C2E"/>
+            <a:srgbClr val="FFFFFF"/>
           </a:solidFill>
           <a:ln w="12700">
             <a:solidFill>
-              <a:srgbClr val="1E293B"/>
+              <a:srgbClr val="E4E0D8"/>
             </a:solidFill>
           </a:ln>
         </p:spPr>
@@ -5561,8 +5627,9 @@
             <a:pPr algn="ctr">
               <a:defRPr sz="1000" b="1">
                 <a:solidFill>
-                  <a:srgbClr val="94A3B8"/>
-                </a:solidFill>
+                  <a:srgbClr val="66625C"/>
+                </a:solidFill>
+                <a:latin typeface="Helvetica"/>
               </a:defRPr>
             </a:pPr>
             <a:r>
@@ -5574,8 +5641,9 @@
             <a:pPr>
               <a:defRPr sz="2200" b="1">
                 <a:solidFill>
-                  <a:srgbClr val="FFFFFF"/>
-                </a:solidFill>
+                  <a:srgbClr val="66625C"/>
+                </a:solidFill>
+                <a:latin typeface="Georgia"/>
               </a:defRPr>
             </a:pPr>
             <a:r>
@@ -5585,10 +5653,11 @@
           </a:p>
           <a:p>
             <a:pPr>
-              <a:defRPr sz="1300" b="1">
-                <a:solidFill>
-                  <a:srgbClr val="FFFFFF"/>
-                </a:solidFill>
+              <a:defRPr sz="1200" b="1">
+                <a:solidFill>
+                  <a:srgbClr val="171717"/>
+                </a:solidFill>
+                <a:latin typeface="Helvetica"/>
               </a:defRPr>
             </a:pPr>
             <a:r>
@@ -5601,8 +5670,9 @@
             <a:pPr>
               <a:defRPr sz="1000">
                 <a:solidFill>
-                  <a:srgbClr val="94A3B8"/>
-                </a:solidFill>
+                  <a:srgbClr val="66625C"/>
+                </a:solidFill>
+                <a:latin typeface="Helvetica"/>
               </a:defRPr>
             </a:pPr>
             <a:r>
@@ -5626,11 +5696,11 @@
             <a:avLst/>
           </a:prstGeom>
           <a:solidFill>
-            <a:srgbClr val="131C2E"/>
+            <a:srgbClr val="F3F0EA"/>
           </a:solidFill>
           <a:ln w="12700">
             <a:solidFill>
-              <a:srgbClr val="1E293B"/>
+              <a:srgbClr val="E4E0D8"/>
             </a:solidFill>
           </a:ln>
         </p:spPr>
@@ -5655,8 +5725,9 @@
             <a:pPr algn="ctr">
               <a:defRPr sz="1100" b="1">
                 <a:solidFill>
-                  <a:srgbClr val="10B981"/>
-                </a:solidFill>
+                  <a:srgbClr val="225E42"/>
+                </a:solidFill>
+                <a:latin typeface="Helvetica"/>
               </a:defRPr>
             </a:pPr>
             <a:r>
@@ -5698,7 +5769,7 @@
             <a:avLst/>
           </a:prstGeom>
           <a:solidFill>
-            <a:srgbClr val="0B0F19"/>
+            <a:srgbClr val="FAF8F5"/>
           </a:solidFill>
           <a:ln>
             <a:noFill/>
@@ -5735,7 +5806,7 @@
         <p:spPr>
           <a:xfrm>
             <a:off x="731520" y="365760"/>
-            <a:ext cx="10698480" cy="365760"/>
+            <a:ext cx="10698480" cy="320040"/>
           </a:xfrm>
           <a:prstGeom prst="rect">
             <a:avLst/>
@@ -5751,7 +5822,7 @@
             <a:pPr>
               <a:defRPr sz="1000" b="1">
                 <a:solidFill>
-                  <a:srgbClr val="10B981"/>
+                  <a:srgbClr val="225E42"/>
                 </a:solidFill>
                 <a:latin typeface="Helvetica"/>
               </a:defRPr>
@@ -5787,9 +5858,9 @@
             <a:pPr>
               <a:defRPr sz="2400" b="1">
                 <a:solidFill>
-                  <a:srgbClr val="FFFFFF"/>
-                </a:solidFill>
-                <a:latin typeface="Helvetica"/>
+                  <a:srgbClr val="171717"/>
+                </a:solidFill>
+                <a:latin typeface="Georgia"/>
               </a:defRPr>
             </a:pPr>
             <a:r>
@@ -5798,9 +5869,9 @@
           </a:p>
           <a:p>
             <a:pPr>
-              <a:defRPr sz="1300">
-                <a:solidFill>
-                  <a:srgbClr val="94A3B8"/>
+              <a:defRPr sz="1200">
+                <a:solidFill>
+                  <a:srgbClr val="66625C"/>
                 </a:solidFill>
                 <a:latin typeface="Helvetica"/>
               </a:defRPr>
@@ -5826,11 +5897,11 @@
             <a:avLst/>
           </a:prstGeom>
           <a:solidFill>
-            <a:srgbClr val="131C2E"/>
+            <a:srgbClr val="FFFFFF"/>
           </a:solidFill>
           <a:ln w="12700">
             <a:solidFill>
-              <a:srgbClr val="1E293B"/>
+              <a:srgbClr val="E4E0D8"/>
             </a:solidFill>
           </a:ln>
         </p:spPr>
@@ -5855,8 +5926,9 @@
             <a:pPr algn="ctr">
               <a:defRPr sz="1100" b="1">
                 <a:solidFill>
-                  <a:srgbClr val="FFFFFF"/>
-                </a:solidFill>
+                  <a:srgbClr val="171717"/>
+                </a:solidFill>
+                <a:latin typeface="Helvetica"/>
               </a:defRPr>
             </a:pPr>
             <a:r>
@@ -5868,8 +5940,9 @@
             <a:pPr>
               <a:defRPr sz="2800" b="1">
                 <a:solidFill>
-                  <a:srgbClr val="FFFFFF"/>
-                </a:solidFill>
+                  <a:srgbClr val="171717"/>
+                </a:solidFill>
+                <a:latin typeface="Georgia"/>
               </a:defRPr>
             </a:pPr>
             <a:r>
@@ -5881,8 +5954,9 @@
             <a:pPr>
               <a:defRPr sz="1600" b="1">
                 <a:solidFill>
-                  <a:srgbClr val="FFFFFF"/>
-                </a:solidFill>
+                  <a:srgbClr val="171717"/>
+                </a:solidFill>
+                <a:latin typeface="Georgia"/>
               </a:defRPr>
             </a:pPr>
             <a:r>
@@ -5895,8 +5969,9 @@
             <a:pPr>
               <a:defRPr sz="1100">
                 <a:solidFill>
-                  <a:srgbClr val="94A3B8"/>
-                </a:solidFill>
+                  <a:srgbClr val="66625C"/>
+                </a:solidFill>
+                <a:latin typeface="Helvetica"/>
               </a:defRPr>
             </a:pPr>
             <a:r>
@@ -5920,11 +5995,11 @@
             <a:avLst/>
           </a:prstGeom>
           <a:solidFill>
-            <a:srgbClr val="131C2E"/>
+            <a:srgbClr val="FFFFFF"/>
           </a:solidFill>
           <a:ln w="12700">
             <a:solidFill>
-              <a:srgbClr val="1E293B"/>
+              <a:srgbClr val="E4E0D8"/>
             </a:solidFill>
           </a:ln>
         </p:spPr>
@@ -5949,8 +6024,9 @@
             <a:pPr algn="ctr">
               <a:defRPr sz="1100" b="1">
                 <a:solidFill>
-                  <a:srgbClr val="14B8A6"/>
-                </a:solidFill>
+                  <a:srgbClr val="A65A24"/>
+                </a:solidFill>
+                <a:latin typeface="Helvetica"/>
               </a:defRPr>
             </a:pPr>
             <a:r>
@@ -5962,8 +6038,9 @@
             <a:pPr>
               <a:defRPr sz="2800" b="1">
                 <a:solidFill>
-                  <a:srgbClr val="14B8A6"/>
-                </a:solidFill>
+                  <a:srgbClr val="A65A24"/>
+                </a:solidFill>
+                <a:latin typeface="Georgia"/>
               </a:defRPr>
             </a:pPr>
             <a:r>
@@ -5975,8 +6052,9 @@
             <a:pPr>
               <a:defRPr sz="1600" b="1">
                 <a:solidFill>
-                  <a:srgbClr val="FFFFFF"/>
-                </a:solidFill>
+                  <a:srgbClr val="171717"/>
+                </a:solidFill>
+                <a:latin typeface="Georgia"/>
               </a:defRPr>
             </a:pPr>
             <a:r>
@@ -5989,8 +6067,9 @@
             <a:pPr>
               <a:defRPr sz="1100">
                 <a:solidFill>
-                  <a:srgbClr val="94A3B8"/>
-                </a:solidFill>
+                  <a:srgbClr val="66625C"/>
+                </a:solidFill>
+                <a:latin typeface="Helvetica"/>
               </a:defRPr>
             </a:pPr>
             <a:r>
@@ -6014,11 +6093,11 @@
             <a:avLst/>
           </a:prstGeom>
           <a:solidFill>
-            <a:srgbClr val="131C2E"/>
+            <a:srgbClr val="FFFFFF"/>
           </a:solidFill>
           <a:ln w="12700">
             <a:solidFill>
-              <a:srgbClr val="1E293B"/>
+              <a:srgbClr val="E4E0D8"/>
             </a:solidFill>
           </a:ln>
         </p:spPr>
@@ -6043,8 +6122,9 @@
             <a:pPr algn="ctr">
               <a:defRPr sz="1100" b="1">
                 <a:solidFill>
-                  <a:srgbClr val="10B981"/>
-                </a:solidFill>
+                  <a:srgbClr val="225E42"/>
+                </a:solidFill>
+                <a:latin typeface="Helvetica"/>
               </a:defRPr>
             </a:pPr>
             <a:r>
@@ -6056,8 +6136,9 @@
             <a:pPr>
               <a:defRPr sz="2800" b="1">
                 <a:solidFill>
-                  <a:srgbClr val="10B981"/>
-                </a:solidFill>
+                  <a:srgbClr val="225E42"/>
+                </a:solidFill>
+                <a:latin typeface="Georgia"/>
               </a:defRPr>
             </a:pPr>
             <a:r>
@@ -6069,8 +6150,9 @@
             <a:pPr>
               <a:defRPr sz="1600" b="1">
                 <a:solidFill>
-                  <a:srgbClr val="FFFFFF"/>
-                </a:solidFill>
+                  <a:srgbClr val="171717"/>
+                </a:solidFill>
+                <a:latin typeface="Georgia"/>
               </a:defRPr>
             </a:pPr>
             <a:r>
@@ -6083,8 +6165,9 @@
             <a:pPr>
               <a:defRPr sz="1100">
                 <a:solidFill>
-                  <a:srgbClr val="94A3B8"/>
-                </a:solidFill>
+                  <a:srgbClr val="66625C"/>
+                </a:solidFill>
+                <a:latin typeface="Helvetica"/>
               </a:defRPr>
             </a:pPr>
             <a:r>
@@ -6108,11 +6191,11 @@
             <a:avLst/>
           </a:prstGeom>
           <a:solidFill>
-            <a:srgbClr val="131C2E"/>
+            <a:srgbClr val="F3F0EA"/>
           </a:solidFill>
           <a:ln w="12700">
             <a:solidFill>
-              <a:srgbClr val="1E293B"/>
+              <a:srgbClr val="E4E0D8"/>
             </a:solidFill>
           </a:ln>
         </p:spPr>
@@ -6137,8 +6220,9 @@
             <a:pPr algn="ctr">
               <a:defRPr sz="1100">
                 <a:solidFill>
-                  <a:srgbClr val="94A3B8"/>
-                </a:solidFill>
+                  <a:srgbClr val="66625C"/>
+                </a:solidFill>
+                <a:latin typeface="Helvetica"/>
               </a:defRPr>
             </a:pPr>
             <a:r>
@@ -6180,7 +6264,7 @@
             <a:avLst/>
           </a:prstGeom>
           <a:solidFill>
-            <a:srgbClr val="0B0F19"/>
+            <a:srgbClr val="FAF8F5"/>
           </a:solidFill>
           <a:ln>
             <a:noFill/>
@@ -6217,7 +6301,7 @@
         <p:spPr>
           <a:xfrm>
             <a:off x="731520" y="365760"/>
-            <a:ext cx="10698480" cy="365760"/>
+            <a:ext cx="10698480" cy="320040"/>
           </a:xfrm>
           <a:prstGeom prst="rect">
             <a:avLst/>
@@ -6233,7 +6317,7 @@
             <a:pPr>
               <a:defRPr sz="1000" b="1">
                 <a:solidFill>
-                  <a:srgbClr val="10B981"/>
+                  <a:srgbClr val="225E42"/>
                 </a:solidFill>
                 <a:latin typeface="Helvetica"/>
               </a:defRPr>
@@ -6269,9 +6353,9 @@
             <a:pPr>
               <a:defRPr sz="2400" b="1">
                 <a:solidFill>
-                  <a:srgbClr val="FFFFFF"/>
-                </a:solidFill>
-                <a:latin typeface="Helvetica"/>
+                  <a:srgbClr val="171717"/>
+                </a:solidFill>
+                <a:latin typeface="Georgia"/>
               </a:defRPr>
             </a:pPr>
             <a:r>
@@ -6280,9 +6364,9 @@
           </a:p>
           <a:p>
             <a:pPr>
-              <a:defRPr sz="1300">
-                <a:solidFill>
-                  <a:srgbClr val="94A3B8"/>
+              <a:defRPr sz="1200">
+                <a:solidFill>
+                  <a:srgbClr val="66625C"/>
                 </a:solidFill>
                 <a:latin typeface="Helvetica"/>
               </a:defRPr>
@@ -6327,8 +6411,9 @@
                       <a:pPr>
                         <a:defRPr sz="1100" b="1">
                           <a:solidFill>
-                            <a:srgbClr val="FFFFFF"/>
+                            <a:srgbClr val="171717"/>
                           </a:solidFill>
+                          <a:latin typeface="Helvetica"/>
                         </a:defRPr>
                       </a:pPr>
                       <a:r>
@@ -6346,8 +6431,9 @@
                       <a:pPr>
                         <a:defRPr sz="1100" b="1">
                           <a:solidFill>
-                            <a:srgbClr val="FFFFFF"/>
+                            <a:srgbClr val="171717"/>
                           </a:solidFill>
+                          <a:latin typeface="Helvetica"/>
                         </a:defRPr>
                       </a:pPr>
                       <a:r>
@@ -6365,8 +6451,9 @@
                       <a:pPr>
                         <a:defRPr sz="1100" b="1">
                           <a:solidFill>
-                            <a:srgbClr val="FFFFFF"/>
+                            <a:srgbClr val="171717"/>
                           </a:solidFill>
+                          <a:latin typeface="Helvetica"/>
                         </a:defRPr>
                       </a:pPr>
                       <a:r>
@@ -6384,8 +6471,9 @@
                       <a:pPr>
                         <a:defRPr sz="1100" b="1">
                           <a:solidFill>
-                            <a:srgbClr val="FFFFFF"/>
+                            <a:srgbClr val="171717"/>
                           </a:solidFill>
+                          <a:latin typeface="Helvetica"/>
                         </a:defRPr>
                       </a:pPr>
                       <a:r>
@@ -6403,8 +6491,9 @@
                       <a:pPr>
                         <a:defRPr sz="1100" b="1">
                           <a:solidFill>
-                            <a:srgbClr val="10B981"/>
+                            <a:srgbClr val="225E42"/>
                           </a:solidFill>
+                          <a:latin typeface="Helvetica"/>
                         </a:defRPr>
                       </a:pPr>
                       <a:r>
@@ -6424,8 +6513,9 @@
                       <a:pPr>
                         <a:defRPr sz="1000">
                           <a:solidFill>
-                            <a:srgbClr val="94A3B8"/>
+                            <a:srgbClr val="66625C"/>
                           </a:solidFill>
+                          <a:latin typeface="Helvetica"/>
                         </a:defRPr>
                       </a:pPr>
                       <a:r>
@@ -6443,8 +6533,9 @@
                       <a:pPr>
                         <a:defRPr sz="1000">
                           <a:solidFill>
-                            <a:srgbClr val="94A3B8"/>
+                            <a:srgbClr val="66625C"/>
                           </a:solidFill>
+                          <a:latin typeface="Helvetica"/>
                         </a:defRPr>
                       </a:pPr>
                       <a:r>
@@ -6462,8 +6553,9 @@
                       <a:pPr>
                         <a:defRPr sz="1000">
                           <a:solidFill>
-                            <a:srgbClr val="94A3B8"/>
+                            <a:srgbClr val="66625C"/>
                           </a:solidFill>
+                          <a:latin typeface="Helvetica"/>
                         </a:defRPr>
                       </a:pPr>
                       <a:r>
@@ -6481,8 +6573,9 @@
                       <a:pPr>
                         <a:defRPr sz="1000">
                           <a:solidFill>
-                            <a:srgbClr val="94A3B8"/>
+                            <a:srgbClr val="66625C"/>
                           </a:solidFill>
+                          <a:latin typeface="Helvetica"/>
                         </a:defRPr>
                       </a:pPr>
                       <a:r>
@@ -6500,8 +6593,9 @@
                       <a:pPr>
                         <a:defRPr sz="1000" b="1">
                           <a:solidFill>
-                            <a:srgbClr val="10B981"/>
+                            <a:srgbClr val="225E42"/>
                           </a:solidFill>
+                          <a:latin typeface="Helvetica"/>
                         </a:defRPr>
                       </a:pPr>
                       <a:r>
@@ -6521,8 +6615,9 @@
                       <a:pPr>
                         <a:defRPr sz="1000">
                           <a:solidFill>
-                            <a:srgbClr val="94A3B8"/>
+                            <a:srgbClr val="66625C"/>
                           </a:solidFill>
+                          <a:latin typeface="Helvetica"/>
                         </a:defRPr>
                       </a:pPr>
                       <a:r>
@@ -6540,8 +6635,9 @@
                       <a:pPr>
                         <a:defRPr sz="1000">
                           <a:solidFill>
-                            <a:srgbClr val="94A3B8"/>
+                            <a:srgbClr val="66625C"/>
                           </a:solidFill>
+                          <a:latin typeface="Helvetica"/>
                         </a:defRPr>
                       </a:pPr>
                       <a:r>
@@ -6559,8 +6655,9 @@
                       <a:pPr>
                         <a:defRPr sz="1000">
                           <a:solidFill>
-                            <a:srgbClr val="94A3B8"/>
+                            <a:srgbClr val="66625C"/>
                           </a:solidFill>
+                          <a:latin typeface="Helvetica"/>
                         </a:defRPr>
                       </a:pPr>
                       <a:r>
@@ -6578,8 +6675,9 @@
                       <a:pPr>
                         <a:defRPr sz="1000">
                           <a:solidFill>
-                            <a:srgbClr val="94A3B8"/>
+                            <a:srgbClr val="66625C"/>
                           </a:solidFill>
+                          <a:latin typeface="Helvetica"/>
                         </a:defRPr>
                       </a:pPr>
                       <a:r>
@@ -6597,8 +6695,9 @@
                       <a:pPr>
                         <a:defRPr sz="1000" b="1">
                           <a:solidFill>
-                            <a:srgbClr val="10B981"/>
+                            <a:srgbClr val="225E42"/>
                           </a:solidFill>
+                          <a:latin typeface="Helvetica"/>
                         </a:defRPr>
                       </a:pPr>
                       <a:r>
@@ -6618,8 +6717,9 @@
                       <a:pPr>
                         <a:defRPr sz="1000">
                           <a:solidFill>
-                            <a:srgbClr val="94A3B8"/>
+                            <a:srgbClr val="66625C"/>
                           </a:solidFill>
+                          <a:latin typeface="Helvetica"/>
                         </a:defRPr>
                       </a:pPr>
                       <a:r>
@@ -6637,8 +6737,9 @@
                       <a:pPr>
                         <a:defRPr sz="1000">
                           <a:solidFill>
-                            <a:srgbClr val="94A3B8"/>
+                            <a:srgbClr val="66625C"/>
                           </a:solidFill>
+                          <a:latin typeface="Helvetica"/>
                         </a:defRPr>
                       </a:pPr>
                       <a:r>
@@ -6656,8 +6757,9 @@
                       <a:pPr>
                         <a:defRPr sz="1000">
                           <a:solidFill>
-                            <a:srgbClr val="94A3B8"/>
+                            <a:srgbClr val="66625C"/>
                           </a:solidFill>
+                          <a:latin typeface="Helvetica"/>
                         </a:defRPr>
                       </a:pPr>
                       <a:r>
@@ -6675,8 +6777,9 @@
                       <a:pPr>
                         <a:defRPr sz="1000">
                           <a:solidFill>
-                            <a:srgbClr val="94A3B8"/>
+                            <a:srgbClr val="66625C"/>
                           </a:solidFill>
+                          <a:latin typeface="Helvetica"/>
                         </a:defRPr>
                       </a:pPr>
                       <a:r>
@@ -6694,8 +6797,9 @@
                       <a:pPr>
                         <a:defRPr sz="1000" b="1">
                           <a:solidFill>
-                            <a:srgbClr val="10B981"/>
+                            <a:srgbClr val="225E42"/>
                           </a:solidFill>
+                          <a:latin typeface="Helvetica"/>
                         </a:defRPr>
                       </a:pPr>
                       <a:r>
@@ -6715,8 +6819,9 @@
                       <a:pPr>
                         <a:defRPr sz="1000">
                           <a:solidFill>
-                            <a:srgbClr val="94A3B8"/>
+                            <a:srgbClr val="66625C"/>
                           </a:solidFill>
+                          <a:latin typeface="Helvetica"/>
                         </a:defRPr>
                       </a:pPr>
                       <a:r>
@@ -6734,8 +6839,9 @@
                       <a:pPr>
                         <a:defRPr sz="1000">
                           <a:solidFill>
-                            <a:srgbClr val="94A3B8"/>
+                            <a:srgbClr val="66625C"/>
                           </a:solidFill>
+                          <a:latin typeface="Helvetica"/>
                         </a:defRPr>
                       </a:pPr>
                       <a:r>
@@ -6753,8 +6859,9 @@
                       <a:pPr>
                         <a:defRPr sz="1000">
                           <a:solidFill>
-                            <a:srgbClr val="94A3B8"/>
+                            <a:srgbClr val="66625C"/>
                           </a:solidFill>
+                          <a:latin typeface="Helvetica"/>
                         </a:defRPr>
                       </a:pPr>
                       <a:r>
@@ -6772,8 +6879,9 @@
                       <a:pPr>
                         <a:defRPr sz="1000">
                           <a:solidFill>
-                            <a:srgbClr val="94A3B8"/>
+                            <a:srgbClr val="66625C"/>
                           </a:solidFill>
+                          <a:latin typeface="Helvetica"/>
                         </a:defRPr>
                       </a:pPr>
                       <a:r>
@@ -6791,8 +6899,9 @@
                       <a:pPr>
                         <a:defRPr sz="1000" b="1">
                           <a:solidFill>
-                            <a:srgbClr val="10B981"/>
+                            <a:srgbClr val="225E42"/>
                           </a:solidFill>
+                          <a:latin typeface="Helvetica"/>
                         </a:defRPr>
                       </a:pPr>
                       <a:r>
@@ -6812,8 +6921,9 @@
                       <a:pPr>
                         <a:defRPr sz="1000">
                           <a:solidFill>
-                            <a:srgbClr val="94A3B8"/>
+                            <a:srgbClr val="66625C"/>
                           </a:solidFill>
+                          <a:latin typeface="Helvetica"/>
                         </a:defRPr>
                       </a:pPr>
                       <a:r>
@@ -6831,8 +6941,9 @@
                       <a:pPr>
                         <a:defRPr sz="1000">
                           <a:solidFill>
-                            <a:srgbClr val="94A3B8"/>
+                            <a:srgbClr val="66625C"/>
                           </a:solidFill>
+                          <a:latin typeface="Helvetica"/>
                         </a:defRPr>
                       </a:pPr>
                       <a:r>
@@ -6850,8 +6961,9 @@
                       <a:pPr>
                         <a:defRPr sz="1000">
                           <a:solidFill>
-                            <a:srgbClr val="94A3B8"/>
+                            <a:srgbClr val="66625C"/>
                           </a:solidFill>
+                          <a:latin typeface="Helvetica"/>
                         </a:defRPr>
                       </a:pPr>
                       <a:r>
@@ -6869,8 +6981,9 @@
                       <a:pPr>
                         <a:defRPr sz="1000">
                           <a:solidFill>
-                            <a:srgbClr val="94A3B8"/>
+                            <a:srgbClr val="66625C"/>
                           </a:solidFill>
+                          <a:latin typeface="Helvetica"/>
                         </a:defRPr>
                       </a:pPr>
                       <a:r>
@@ -6888,8 +7001,9 @@
                       <a:pPr>
                         <a:defRPr sz="1000" b="1">
                           <a:solidFill>
-                            <a:srgbClr val="10B981"/>
+                            <a:srgbClr val="225E42"/>
                           </a:solidFill>
+                          <a:latin typeface="Helvetica"/>
                         </a:defRPr>
                       </a:pPr>
                       <a:r>
@@ -6937,7 +7051,7 @@
             <a:avLst/>
           </a:prstGeom>
           <a:solidFill>
-            <a:srgbClr val="0B0F19"/>
+            <a:srgbClr val="FAF8F5"/>
           </a:solidFill>
           <a:ln>
             <a:noFill/>
@@ -6974,7 +7088,7 @@
         <p:spPr>
           <a:xfrm>
             <a:off x="731520" y="365760"/>
-            <a:ext cx="10698480" cy="365760"/>
+            <a:ext cx="10698480" cy="320040"/>
           </a:xfrm>
           <a:prstGeom prst="rect">
             <a:avLst/>
@@ -6990,7 +7104,7 @@
             <a:pPr>
               <a:defRPr sz="1000" b="1">
                 <a:solidFill>
-                  <a:srgbClr val="10B981"/>
+                  <a:srgbClr val="225E42"/>
                 </a:solidFill>
                 <a:latin typeface="Helvetica"/>
               </a:defRPr>
@@ -7026,9 +7140,9 @@
             <a:pPr>
               <a:defRPr sz="2400" b="1">
                 <a:solidFill>
-                  <a:srgbClr val="FFFFFF"/>
-                </a:solidFill>
-                <a:latin typeface="Helvetica"/>
+                  <a:srgbClr val="171717"/>
+                </a:solidFill>
+                <a:latin typeface="Georgia"/>
               </a:defRPr>
             </a:pPr>
             <a:r>
@@ -7037,9 +7151,9 @@
           </a:p>
           <a:p>
             <a:pPr>
-              <a:defRPr sz="1300">
-                <a:solidFill>
-                  <a:srgbClr val="94A3B8"/>
+              <a:defRPr sz="1200">
+                <a:solidFill>
+                  <a:srgbClr val="66625C"/>
                 </a:solidFill>
                 <a:latin typeface="Helvetica"/>
               </a:defRPr>
@@ -7065,11 +7179,11 @@
             <a:avLst/>
           </a:prstGeom>
           <a:solidFill>
-            <a:srgbClr val="131C2E"/>
+            <a:srgbClr val="FFFFFF"/>
           </a:solidFill>
           <a:ln w="12700">
             <a:solidFill>
-              <a:srgbClr val="1E293B"/>
+              <a:srgbClr val="E4E0D8"/>
             </a:solidFill>
           </a:ln>
         </p:spPr>
@@ -7094,8 +7208,9 @@
             <a:pPr algn="ctr">
               <a:defRPr sz="1400" b="1">
                 <a:solidFill>
-                  <a:srgbClr val="FFFFFF"/>
-                </a:solidFill>
+                  <a:srgbClr val="171717"/>
+                </a:solidFill>
+                <a:latin typeface="Georgia"/>
               </a:defRPr>
             </a:pPr>
             <a:r>
@@ -7107,8 +7222,9 @@
             <a:pPr>
               <a:defRPr sz="1200" b="1">
                 <a:solidFill>
-                  <a:srgbClr val="10B981"/>
-                </a:solidFill>
+                  <a:srgbClr val="225E42"/>
+                </a:solidFill>
+                <a:latin typeface="Helvetica"/>
               </a:defRPr>
             </a:pPr>
             <a:r>
@@ -7120,8 +7236,9 @@
             <a:pPr>
               <a:defRPr sz="1050">
                 <a:solidFill>
-                  <a:srgbClr val="94A3B8"/>
-                </a:solidFill>
+                  <a:srgbClr val="66625C"/>
+                </a:solidFill>
+                <a:latin typeface="Helvetica"/>
               </a:defRPr>
             </a:pPr>
             <a:r>
@@ -7133,8 +7250,9 @@
             <a:pPr>
               <a:defRPr sz="1200" b="1">
                 <a:solidFill>
-                  <a:srgbClr val="10B981"/>
-                </a:solidFill>
+                  <a:srgbClr val="225E42"/>
+                </a:solidFill>
+                <a:latin typeface="Helvetica"/>
               </a:defRPr>
             </a:pPr>
             <a:r>
@@ -7146,8 +7264,9 @@
             <a:pPr>
               <a:defRPr sz="1050">
                 <a:solidFill>
-                  <a:srgbClr val="94A3B8"/>
-                </a:solidFill>
+                  <a:srgbClr val="66625C"/>
+                </a:solidFill>
+                <a:latin typeface="Helvetica"/>
               </a:defRPr>
             </a:pPr>
             <a:r>
@@ -7159,8 +7278,9 @@
             <a:pPr>
               <a:defRPr sz="1200" b="1">
                 <a:solidFill>
-                  <a:srgbClr val="10B981"/>
-                </a:solidFill>
+                  <a:srgbClr val="225E42"/>
+                </a:solidFill>
+                <a:latin typeface="Helvetica"/>
               </a:defRPr>
             </a:pPr>
             <a:r>
@@ -7172,8 +7292,9 @@
             <a:pPr>
               <a:defRPr sz="1050">
                 <a:solidFill>
-                  <a:srgbClr val="94A3B8"/>
-                </a:solidFill>
+                  <a:srgbClr val="66625C"/>
+                </a:solidFill>
+                <a:latin typeface="Helvetica"/>
               </a:defRPr>
             </a:pPr>
             <a:r>
@@ -7185,8 +7306,9 @@
             <a:pPr>
               <a:defRPr sz="1200" b="1">
                 <a:solidFill>
-                  <a:srgbClr val="10B981"/>
-                </a:solidFill>
+                  <a:srgbClr val="225E42"/>
+                </a:solidFill>
+                <a:latin typeface="Helvetica"/>
               </a:defRPr>
             </a:pPr>
             <a:r>
@@ -7198,8 +7320,9 @@
             <a:pPr>
               <a:defRPr sz="1050">
                 <a:solidFill>
-                  <a:srgbClr val="94A3B8"/>
-                </a:solidFill>
+                  <a:srgbClr val="66625C"/>
+                </a:solidFill>
+                <a:latin typeface="Helvetica"/>
               </a:defRPr>
             </a:pPr>
             <a:r>
@@ -7224,11 +7347,11 @@
             <a:avLst/>
           </a:prstGeom>
           <a:solidFill>
-            <a:srgbClr val="131C2E"/>
+            <a:srgbClr val="F1F7F3"/>
           </a:solidFill>
           <a:ln w="12700">
             <a:solidFill>
-              <a:srgbClr val="10B981"/>
+              <a:srgbClr val="225E42"/>
             </a:solidFill>
           </a:ln>
         </p:spPr>
@@ -7251,10 +7374,11 @@
           <a:lstStyle/>
           <a:p>
             <a:pPr algn="ctr">
-              <a:defRPr sz="1200" b="1">
-                <a:solidFill>
-                  <a:srgbClr val="10B981"/>
-                </a:solidFill>
+              <a:defRPr sz="1100" b="1">
+                <a:solidFill>
+                  <a:srgbClr val="225E42"/>
+                </a:solidFill>
+                <a:latin typeface="Helvetica"/>
               </a:defRPr>
             </a:pPr>
             <a:r>
@@ -7266,8 +7390,9 @@
             <a:pPr>
               <a:defRPr sz="2200" b="1">
                 <a:solidFill>
-                  <a:srgbClr val="FFFFFF"/>
-                </a:solidFill>
+                  <a:srgbClr val="171717"/>
+                </a:solidFill>
+                <a:latin typeface="Georgia"/>
               </a:defRPr>
             </a:pPr>
             <a:r>
@@ -7278,10 +7403,11 @@
           </a:p>
           <a:p>
             <a:pPr>
-              <a:defRPr sz="1200">
-                <a:solidFill>
-                  <a:srgbClr val="94A3B8"/>
-                </a:solidFill>
+              <a:defRPr sz="1150">
+                <a:solidFill>
+                  <a:srgbClr val="66625C"/>
+                </a:solidFill>
+                <a:latin typeface="Helvetica"/>
               </a:defRPr>
             </a:pPr>
             <a:r>
@@ -7294,8 +7420,9 @@
             <a:pPr>
               <a:defRPr sz="1100" b="1">
                 <a:solidFill>
-                  <a:srgbClr val="FFFFFF"/>
-                </a:solidFill>
+                  <a:srgbClr val="171717"/>
+                </a:solidFill>
+                <a:latin typeface="Helvetica"/>
               </a:defRPr>
             </a:pPr>
             <a:r>
@@ -7306,8 +7433,9 @@
             <a:pPr>
               <a:defRPr sz="1100">
                 <a:solidFill>
-                  <a:srgbClr val="10B981"/>
-                </a:solidFill>
+                  <a:srgbClr val="225E42"/>
+                </a:solidFill>
+                <a:latin typeface="Helvetica"/>
               </a:defRPr>
             </a:pPr>
             <a:r>
@@ -7349,7 +7477,7 @@
             <a:avLst/>
           </a:prstGeom>
           <a:solidFill>
-            <a:srgbClr val="0B0F19"/>
+            <a:srgbClr val="FAF8F5"/>
           </a:solidFill>
           <a:ln>
             <a:noFill/>
@@ -7386,7 +7514,7 @@
         <p:spPr>
           <a:xfrm>
             <a:off x="731520" y="365760"/>
-            <a:ext cx="10698480" cy="365760"/>
+            <a:ext cx="10698480" cy="320040"/>
           </a:xfrm>
           <a:prstGeom prst="rect">
             <a:avLst/>
@@ -7402,7 +7530,7 @@
             <a:pPr>
               <a:defRPr sz="1000" b="1">
                 <a:solidFill>
-                  <a:srgbClr val="10B981"/>
+                  <a:srgbClr val="225E42"/>
                 </a:solidFill>
                 <a:latin typeface="Helvetica"/>
               </a:defRPr>
@@ -7438,9 +7566,9 @@
             <a:pPr>
               <a:defRPr sz="2400" b="1">
                 <a:solidFill>
-                  <a:srgbClr val="FFFFFF"/>
-                </a:solidFill>
-                <a:latin typeface="Helvetica"/>
+                  <a:srgbClr val="171717"/>
+                </a:solidFill>
+                <a:latin typeface="Georgia"/>
               </a:defRPr>
             </a:pPr>
             <a:r>
@@ -7449,15 +7577,15 @@
           </a:p>
           <a:p>
             <a:pPr>
-              <a:defRPr sz="1300">
-                <a:solidFill>
-                  <a:srgbClr val="94A3B8"/>
-                </a:solidFill>
-                <a:latin typeface="Helvetica"/>
-              </a:defRPr>
-            </a:pPr>
-            <a:r>
-              <a:t>How 54-day payment cycles paralyze global supply chains</a:t>
+              <a:defRPr sz="1200">
+                <a:solidFill>
+                  <a:srgbClr val="66625C"/>
+                </a:solidFill>
+                <a:latin typeface="Helvetica"/>
+              </a:defRPr>
+            </a:pPr>
+            <a:r>
+              <a:t>How 54-day payment cycles paralyze global enterprise supply chains</a:t>
             </a:r>
           </a:p>
         </p:txBody>
@@ -7471,17 +7599,17 @@
         <p:spPr>
           <a:xfrm>
             <a:off x="731520" y="1645920"/>
-            <a:ext cx="3291840" cy="2377440"/>
+            <a:ext cx="3291840" cy="2468880"/>
           </a:xfrm>
           <a:prstGeom prst="roundRect">
             <a:avLst/>
           </a:prstGeom>
           <a:solidFill>
-            <a:srgbClr val="131C2E"/>
+            <a:srgbClr val="FFFFFF"/>
           </a:solidFill>
           <a:ln w="12700">
             <a:solidFill>
-              <a:srgbClr val="EF4444"/>
+              <a:srgbClr val="B91C1C"/>
             </a:solidFill>
           </a:ln>
         </p:spPr>
@@ -7506,8 +7634,9 @@
             <a:pPr algn="ctr">
               <a:defRPr sz="3200" b="1">
                 <a:solidFill>
-                  <a:srgbClr val="EF4444"/>
-                </a:solidFill>
+                  <a:srgbClr val="B91C1C"/>
+                </a:solidFill>
+                <a:latin typeface="Georgia"/>
               </a:defRPr>
             </a:pPr>
             <a:r>
@@ -7517,10 +7646,11 @@
           </a:p>
           <a:p>
             <a:pPr>
-              <a:defRPr sz="1400" b="1">
-                <a:solidFill>
-                  <a:srgbClr val="FFFFFF"/>
-                </a:solidFill>
+              <a:defRPr sz="1300" b="1">
+                <a:solidFill>
+                  <a:srgbClr val="171717"/>
+                </a:solidFill>
+                <a:latin typeface="Helvetica"/>
               </a:defRPr>
             </a:pPr>
             <a:r>
@@ -7532,8 +7662,9 @@
             <a:pPr>
               <a:defRPr sz="1100">
                 <a:solidFill>
-                  <a:srgbClr val="94A3B8"/>
-                </a:solidFill>
+                  <a:srgbClr val="66625C"/>
+                </a:solidFill>
+                <a:latin typeface="Helvetica"/>
               </a:defRPr>
             </a:pPr>
             <a:r>
@@ -7551,17 +7682,17 @@
         <p:spPr>
           <a:xfrm>
             <a:off x="4389120" y="1645920"/>
-            <a:ext cx="3291840" cy="2377440"/>
+            <a:ext cx="3291840" cy="2468880"/>
           </a:xfrm>
           <a:prstGeom prst="roundRect">
             <a:avLst/>
           </a:prstGeom>
           <a:solidFill>
-            <a:srgbClr val="131C2E"/>
+            <a:srgbClr val="FFFFFF"/>
           </a:solidFill>
           <a:ln w="12700">
             <a:solidFill>
-              <a:srgbClr val="F59E0B"/>
+              <a:srgbClr val="A65A24"/>
             </a:solidFill>
           </a:ln>
         </p:spPr>
@@ -7586,8 +7717,9 @@
             <a:pPr algn="ctr">
               <a:defRPr sz="3200" b="1">
                 <a:solidFill>
-                  <a:srgbClr val="F59E0B"/>
-                </a:solidFill>
+                  <a:srgbClr val="A65A24"/>
+                </a:solidFill>
+                <a:latin typeface="Georgia"/>
               </a:defRPr>
             </a:pPr>
             <a:r>
@@ -7597,10 +7729,11 @@
           </a:p>
           <a:p>
             <a:pPr>
-              <a:defRPr sz="1400" b="1">
-                <a:solidFill>
-                  <a:srgbClr val="FFFFFF"/>
-                </a:solidFill>
+              <a:defRPr sz="1300" b="1">
+                <a:solidFill>
+                  <a:srgbClr val="171717"/>
+                </a:solidFill>
+                <a:latin typeface="Helvetica"/>
               </a:defRPr>
             </a:pPr>
             <a:r>
@@ -7612,8 +7745,9 @@
             <a:pPr>
               <a:defRPr sz="1100">
                 <a:solidFill>
-                  <a:srgbClr val="94A3B8"/>
-                </a:solidFill>
+                  <a:srgbClr val="66625C"/>
+                </a:solidFill>
+                <a:latin typeface="Helvetica"/>
               </a:defRPr>
             </a:pPr>
             <a:r>
@@ -7631,17 +7765,17 @@
         <p:spPr>
           <a:xfrm>
             <a:off x="8046720" y="1645920"/>
-            <a:ext cx="3291840" cy="2377440"/>
+            <a:ext cx="3291840" cy="2468880"/>
           </a:xfrm>
           <a:prstGeom prst="roundRect">
             <a:avLst/>
           </a:prstGeom>
           <a:solidFill>
-            <a:srgbClr val="131C2E"/>
+            <a:srgbClr val="FFFFFF"/>
           </a:solidFill>
           <a:ln w="12700">
             <a:solidFill>
-              <a:srgbClr val="1E293B"/>
+              <a:srgbClr val="E4E0D8"/>
             </a:solidFill>
           </a:ln>
         </p:spPr>
@@ -7666,8 +7800,9 @@
             <a:pPr algn="ctr">
               <a:defRPr sz="3200" b="1">
                 <a:solidFill>
-                  <a:srgbClr val="FFFFFF"/>
-                </a:solidFill>
+                  <a:srgbClr val="171717"/>
+                </a:solidFill>
+                <a:latin typeface="Georgia"/>
               </a:defRPr>
             </a:pPr>
             <a:r>
@@ -7677,10 +7812,11 @@
           </a:p>
           <a:p>
             <a:pPr>
-              <a:defRPr sz="1400" b="1">
-                <a:solidFill>
-                  <a:srgbClr val="FFFFFF"/>
-                </a:solidFill>
+              <a:defRPr sz="1300" b="1">
+                <a:solidFill>
+                  <a:srgbClr val="171717"/>
+                </a:solidFill>
+                <a:latin typeface="Helvetica"/>
               </a:defRPr>
             </a:pPr>
             <a:r>
@@ -7692,12 +7828,13 @@
             <a:pPr>
               <a:defRPr sz="1100">
                 <a:solidFill>
-                  <a:srgbClr val="94A3B8"/>
-                </a:solidFill>
-              </a:defRPr>
-            </a:pPr>
-            <a:r>
-              <a:t>Consumer commerce moved to instant VISA chips in seconds. B2B payments still run on static PDFs, manual IBAN wires, and email chasing.</a:t>
+                  <a:srgbClr val="66625C"/>
+                </a:solidFill>
+                <a:latin typeface="Helvetica"/>
+              </a:defRPr>
+            </a:pPr>
+            <a:r>
+              <a:t>Consumer commerce moved to instant card clearing in seconds. B2B payments still run on static PDFs, manual IBAN wires, and email chasing.</a:t>
             </a:r>
           </a:p>
         </p:txBody>
@@ -7717,11 +7854,11 @@
             <a:avLst/>
           </a:prstGeom>
           <a:solidFill>
-            <a:srgbClr val="131C2E"/>
+            <a:srgbClr val="FEF2F2"/>
           </a:solidFill>
           <a:ln w="12700">
             <a:solidFill>
-              <a:srgbClr val="1E293B"/>
+              <a:srgbClr val="B91C1C"/>
             </a:solidFill>
           </a:ln>
         </p:spPr>
@@ -7744,10 +7881,11 @@
           <a:lstStyle/>
           <a:p>
             <a:pPr algn="ctr">
-              <a:defRPr sz="1200" b="1">
-                <a:solidFill>
-                  <a:srgbClr val="EF4444"/>
-                </a:solidFill>
+              <a:defRPr sz="1100" b="1">
+                <a:solidFill>
+                  <a:srgbClr val="B91C1C"/>
+                </a:solidFill>
+                <a:latin typeface="Helvetica"/>
               </a:defRPr>
             </a:pPr>
             <a:r>
@@ -7759,8 +7897,9 @@
             <a:pPr>
               <a:defRPr sz="1200">
                 <a:solidFill>
-                  <a:srgbClr val="94A3B8"/>
-                </a:solidFill>
+                  <a:srgbClr val="171717"/>
+                </a:solidFill>
+                <a:latin typeface="Helvetica"/>
               </a:defRPr>
             </a:pPr>
             <a:r>
@@ -7802,7 +7941,7 @@
             <a:avLst/>
           </a:prstGeom>
           <a:solidFill>
-            <a:srgbClr val="0B0F19"/>
+            <a:srgbClr val="FAF8F5"/>
           </a:solidFill>
           <a:ln>
             <a:noFill/>
@@ -7839,7 +7978,7 @@
         <p:spPr>
           <a:xfrm>
             <a:off x="731520" y="365760"/>
-            <a:ext cx="10698480" cy="365760"/>
+            <a:ext cx="10698480" cy="320040"/>
           </a:xfrm>
           <a:prstGeom prst="rect">
             <a:avLst/>
@@ -7855,7 +7994,7 @@
             <a:pPr>
               <a:defRPr sz="1000" b="1">
                 <a:solidFill>
-                  <a:srgbClr val="10B981"/>
+                  <a:srgbClr val="225E42"/>
                 </a:solidFill>
                 <a:latin typeface="Helvetica"/>
               </a:defRPr>
@@ -7891,9 +8030,9 @@
             <a:pPr>
               <a:defRPr sz="2400" b="1">
                 <a:solidFill>
-                  <a:srgbClr val="FFFFFF"/>
-                </a:solidFill>
-                <a:latin typeface="Helvetica"/>
+                  <a:srgbClr val="171717"/>
+                </a:solidFill>
+                <a:latin typeface="Georgia"/>
               </a:defRPr>
             </a:pPr>
             <a:r>
@@ -7902,9 +8041,9 @@
           </a:p>
           <a:p>
             <a:pPr>
-              <a:defRPr sz="1300">
-                <a:solidFill>
-                  <a:srgbClr val="94A3B8"/>
+              <a:defRPr sz="1200">
+                <a:solidFill>
+                  <a:srgbClr val="66625C"/>
                 </a:solidFill>
                 <a:latin typeface="Helvetica"/>
               </a:defRPr>
@@ -7930,11 +8069,11 @@
             <a:avLst/>
           </a:prstGeom>
           <a:solidFill>
-            <a:srgbClr val="131C2E"/>
+            <a:srgbClr val="FFFFFF"/>
           </a:solidFill>
           <a:ln w="12700">
             <a:solidFill>
-              <a:srgbClr val="1E293B"/>
+              <a:srgbClr val="E4E0D8"/>
             </a:solidFill>
           </a:ln>
         </p:spPr>
@@ -7957,10 +8096,11 @@
           <a:lstStyle/>
           <a:p>
             <a:pPr algn="ctr">
-              <a:defRPr sz="1400" b="1">
-                <a:solidFill>
-                  <a:srgbClr val="EF4444"/>
-                </a:solidFill>
+              <a:defRPr sz="1300" b="1">
+                <a:solidFill>
+                  <a:srgbClr val="B91C1C"/>
+                </a:solidFill>
+                <a:latin typeface="Helvetica"/>
               </a:defRPr>
             </a:pPr>
             <a:r>
@@ -7970,10 +8110,11 @@
           </a:p>
           <a:p>
             <a:pPr>
-              <a:defRPr sz="1200">
-                <a:solidFill>
-                  <a:srgbClr val="FFFFFF"/>
-                </a:solidFill>
+              <a:defRPr sz="1150">
+                <a:solidFill>
+                  <a:srgbClr val="171717"/>
+                </a:solidFill>
+                <a:latin typeface="Helvetica"/>
               </a:defRPr>
             </a:pPr>
             <a:r>
@@ -7983,10 +8124,11 @@
           </a:p>
           <a:p>
             <a:pPr>
-              <a:defRPr sz="1200">
-                <a:solidFill>
-                  <a:srgbClr val="FFFFFF"/>
-                </a:solidFill>
+              <a:defRPr sz="1150">
+                <a:solidFill>
+                  <a:srgbClr val="171717"/>
+                </a:solidFill>
+                <a:latin typeface="Helvetica"/>
               </a:defRPr>
             </a:pPr>
             <a:r>
@@ -7996,10 +8138,11 @@
           </a:p>
           <a:p>
             <a:pPr>
-              <a:defRPr sz="1200">
-                <a:solidFill>
-                  <a:srgbClr val="FFFFFF"/>
-                </a:solidFill>
+              <a:defRPr sz="1150">
+                <a:solidFill>
+                  <a:srgbClr val="171717"/>
+                </a:solidFill>
+                <a:latin typeface="Helvetica"/>
               </a:defRPr>
             </a:pPr>
             <a:r>
@@ -8009,10 +8152,11 @@
           </a:p>
           <a:p>
             <a:pPr>
-              <a:defRPr sz="1200">
-                <a:solidFill>
-                  <a:srgbClr val="FFFFFF"/>
-                </a:solidFill>
+              <a:defRPr sz="1150">
+                <a:solidFill>
+                  <a:srgbClr val="171717"/>
+                </a:solidFill>
+                <a:latin typeface="Helvetica"/>
               </a:defRPr>
             </a:pPr>
             <a:r>
@@ -8037,11 +8181,11 @@
             <a:avLst/>
           </a:prstGeom>
           <a:solidFill>
-            <a:srgbClr val="131C2E"/>
+            <a:srgbClr val="FFFFFF"/>
           </a:solidFill>
           <a:ln w="12700">
             <a:solidFill>
-              <a:srgbClr val="1E293B"/>
+              <a:srgbClr val="A65A24"/>
             </a:solidFill>
           </a:ln>
         </p:spPr>
@@ -8064,10 +8208,11 @@
           <a:lstStyle/>
           <a:p>
             <a:pPr algn="ctr">
-              <a:defRPr sz="1400" b="1">
-                <a:solidFill>
-                  <a:srgbClr val="F59E0B"/>
-                </a:solidFill>
+              <a:defRPr sz="1300" b="1">
+                <a:solidFill>
+                  <a:srgbClr val="A65A24"/>
+                </a:solidFill>
+                <a:latin typeface="Helvetica"/>
               </a:defRPr>
             </a:pPr>
             <a:r>
@@ -8077,10 +8222,11 @@
           </a:p>
           <a:p>
             <a:pPr>
-              <a:defRPr sz="1200">
-                <a:solidFill>
-                  <a:srgbClr val="94A3B8"/>
-                </a:solidFill>
+              <a:defRPr sz="1150">
+                <a:solidFill>
+                  <a:srgbClr val="66625C"/>
+                </a:solidFill>
+                <a:latin typeface="Helvetica"/>
               </a:defRPr>
             </a:pPr>
             <a:r>
@@ -8090,22 +8236,24 @@
           </a:p>
           <a:p>
             <a:pPr>
-              <a:defRPr sz="1200" b="1">
-                <a:solidFill>
-                  <a:srgbClr val="FFFFFF"/>
-                </a:solidFill>
-              </a:defRPr>
-            </a:pPr>
-            <a:r>
-              <a:t>  1. No real-time bank cash balance (PSD2)</a:t>
-            </a:r>
-          </a:p>
-          <a:p>
-            <a:pPr>
-              <a:defRPr sz="1200" b="1">
-                <a:solidFill>
-                  <a:srgbClr val="FFFFFF"/>
-                </a:solidFill>
+              <a:defRPr sz="1150" b="1">
+                <a:solidFill>
+                  <a:srgbClr val="171717"/>
+                </a:solidFill>
+                <a:latin typeface="Helvetica"/>
+              </a:defRPr>
+            </a:pPr>
+            <a:r>
+              <a:t>  1. No real-time bank cash balance (PSD2 Open Banking)</a:t>
+            </a:r>
+          </a:p>
+          <a:p>
+            <a:pPr>
+              <a:defRPr sz="1150" b="1">
+                <a:solidFill>
+                  <a:srgbClr val="171717"/>
+                </a:solidFill>
+                <a:latin typeface="Helvetica"/>
               </a:defRPr>
             </a:pPr>
             <a:r>
@@ -8114,10 +8262,11 @@
           </a:p>
           <a:p>
             <a:pPr>
-              <a:defRPr sz="1200" b="1">
-                <a:solidFill>
-                  <a:srgbClr val="FFFFFF"/>
-                </a:solidFill>
+              <a:defRPr sz="1150" b="1">
+                <a:solidFill>
+                  <a:srgbClr val="171717"/>
+                </a:solidFill>
+                <a:latin typeface="Helvetica"/>
               </a:defRPr>
             </a:pPr>
             <a:r>
@@ -8126,10 +8275,11 @@
           </a:p>
           <a:p>
             <a:pPr>
-              <a:defRPr sz="1200" b="1">
-                <a:solidFill>
-                  <a:srgbClr val="FFFFFF"/>
-                </a:solidFill>
+              <a:defRPr sz="1150" b="1">
+                <a:solidFill>
+                  <a:srgbClr val="171717"/>
+                </a:solidFill>
+                <a:latin typeface="Helvetica"/>
               </a:defRPr>
             </a:pPr>
             <a:r>
@@ -8171,7 +8321,7 @@
             <a:avLst/>
           </a:prstGeom>
           <a:solidFill>
-            <a:srgbClr val="0B0F19"/>
+            <a:srgbClr val="FAF8F5"/>
           </a:solidFill>
           <a:ln>
             <a:noFill/>
@@ -8208,7 +8358,7 @@
         <p:spPr>
           <a:xfrm>
             <a:off x="731520" y="365760"/>
-            <a:ext cx="10698480" cy="365760"/>
+            <a:ext cx="10698480" cy="320040"/>
           </a:xfrm>
           <a:prstGeom prst="rect">
             <a:avLst/>
@@ -8224,7 +8374,7 @@
             <a:pPr>
               <a:defRPr sz="1000" b="1">
                 <a:solidFill>
-                  <a:srgbClr val="10B981"/>
+                  <a:srgbClr val="225E42"/>
                 </a:solidFill>
                 <a:latin typeface="Helvetica"/>
               </a:defRPr>
@@ -8260,9 +8410,9 @@
             <a:pPr>
               <a:defRPr sz="2400" b="1">
                 <a:solidFill>
-                  <a:srgbClr val="FFFFFF"/>
-                </a:solidFill>
-                <a:latin typeface="Helvetica"/>
+                  <a:srgbClr val="171717"/>
+                </a:solidFill>
+                <a:latin typeface="Georgia"/>
               </a:defRPr>
             </a:pPr>
             <a:r>
@@ -8271,9 +8421,9 @@
           </a:p>
           <a:p>
             <a:pPr>
-              <a:defRPr sz="1300">
-                <a:solidFill>
-                  <a:srgbClr val="94A3B8"/>
+              <a:defRPr sz="1200">
+                <a:solidFill>
+                  <a:srgbClr val="66625C"/>
                 </a:solidFill>
                 <a:latin typeface="Helvetica"/>
               </a:defRPr>
@@ -8299,11 +8449,11 @@
             <a:avLst/>
           </a:prstGeom>
           <a:solidFill>
-            <a:srgbClr val="131C2E"/>
+            <a:srgbClr val="FFFFFF"/>
           </a:solidFill>
           <a:ln w="12700">
             <a:solidFill>
-              <a:srgbClr val="1E293B"/>
+              <a:srgbClr val="E4E0D8"/>
             </a:solidFill>
           </a:ln>
         </p:spPr>
@@ -8326,10 +8476,11 @@
           <a:lstStyle/>
           <a:p>
             <a:pPr algn="ctr">
-              <a:defRPr sz="1200" b="1">
-                <a:solidFill>
-                  <a:srgbClr val="F59E0B"/>
-                </a:solidFill>
+              <a:defRPr sz="1100" b="1">
+                <a:solidFill>
+                  <a:srgbClr val="A65A24"/>
+                </a:solidFill>
+                <a:latin typeface="Helvetica"/>
               </a:defRPr>
             </a:pPr>
             <a:r>
@@ -8341,8 +8492,9 @@
             <a:pPr>
               <a:defRPr sz="1800" b="1">
                 <a:solidFill>
-                  <a:srgbClr val="FFFFFF"/>
-                </a:solidFill>
+                  <a:srgbClr val="171717"/>
+                </a:solidFill>
+                <a:latin typeface="Georgia"/>
               </a:defRPr>
             </a:pPr>
             <a:r>
@@ -8352,10 +8504,11 @@
           </a:p>
           <a:p>
             <a:pPr>
-              <a:defRPr sz="1200">
-                <a:solidFill>
-                  <a:srgbClr val="94A3B8"/>
-                </a:solidFill>
+              <a:defRPr sz="1150">
+                <a:solidFill>
+                  <a:srgbClr val="66625C"/>
+                </a:solidFill>
+                <a:latin typeface="Helvetica"/>
               </a:defRPr>
             </a:pPr>
             <a:r>
@@ -8367,8 +8520,9 @@
             <a:pPr>
               <a:defRPr sz="1100" b="1">
                 <a:solidFill>
-                  <a:srgbClr val="F59E0B"/>
-                </a:solidFill>
+                  <a:srgbClr val="A65A24"/>
+                </a:solidFill>
+                <a:latin typeface="Helvetica"/>
               </a:defRPr>
             </a:pPr>
             <a:r>
@@ -8392,11 +8546,11 @@
             <a:avLst/>
           </a:prstGeom>
           <a:solidFill>
-            <a:srgbClr val="131C2E"/>
+            <a:srgbClr val="FFFFFF"/>
           </a:solidFill>
           <a:ln w="12700">
             <a:solidFill>
-              <a:srgbClr val="10B981"/>
+              <a:srgbClr val="225E42"/>
             </a:solidFill>
           </a:ln>
         </p:spPr>
@@ -8419,10 +8573,11 @@
           <a:lstStyle/>
           <a:p>
             <a:pPr algn="ctr">
-              <a:defRPr sz="1200" b="1">
-                <a:solidFill>
-                  <a:srgbClr val="10B981"/>
-                </a:solidFill>
+              <a:defRPr sz="1100" b="1">
+                <a:solidFill>
+                  <a:srgbClr val="225E42"/>
+                </a:solidFill>
+                <a:latin typeface="Helvetica"/>
               </a:defRPr>
             </a:pPr>
             <a:r>
@@ -8434,8 +8589,9 @@
             <a:pPr>
               <a:defRPr sz="1800" b="1">
                 <a:solidFill>
-                  <a:srgbClr val="FFFFFF"/>
-                </a:solidFill>
+                  <a:srgbClr val="171717"/>
+                </a:solidFill>
+                <a:latin typeface="Georgia"/>
               </a:defRPr>
             </a:pPr>
             <a:r>
@@ -8445,10 +8601,11 @@
           </a:p>
           <a:p>
             <a:pPr>
-              <a:defRPr sz="1200">
-                <a:solidFill>
-                  <a:srgbClr val="94A3B8"/>
-                </a:solidFill>
+              <a:defRPr sz="1150">
+                <a:solidFill>
+                  <a:srgbClr val="66625C"/>
+                </a:solidFill>
+                <a:latin typeface="Helvetica"/>
               </a:defRPr>
             </a:pPr>
             <a:r>
@@ -8460,8 +8617,9 @@
             <a:pPr>
               <a:defRPr sz="1100" b="1">
                 <a:solidFill>
-                  <a:srgbClr val="10B981"/>
-                </a:solidFill>
+                  <a:srgbClr val="225E42"/>
+                </a:solidFill>
+                <a:latin typeface="Helvetica"/>
               </a:defRPr>
             </a:pPr>
             <a:r>
@@ -8485,11 +8643,11 @@
             <a:avLst/>
           </a:prstGeom>
           <a:solidFill>
-            <a:srgbClr val="131C2E"/>
+            <a:srgbClr val="F3F0EA"/>
           </a:solidFill>
           <a:ln w="12700">
             <a:solidFill>
-              <a:srgbClr val="1E293B"/>
+              <a:srgbClr val="E4E0D8"/>
             </a:solidFill>
           </a:ln>
         </p:spPr>
@@ -8512,10 +8670,11 @@
           <a:lstStyle/>
           <a:p>
             <a:pPr algn="ctr">
-              <a:defRPr sz="1200" b="1">
-                <a:solidFill>
-                  <a:srgbClr val="FFFFFF"/>
-                </a:solidFill>
+              <a:defRPr sz="1150" b="1">
+                <a:solidFill>
+                  <a:srgbClr val="171717"/>
+                </a:solidFill>
+                <a:latin typeface="Helvetica"/>
               </a:defRPr>
             </a:pPr>
             <a:r>
@@ -8557,7 +8716,7 @@
             <a:avLst/>
           </a:prstGeom>
           <a:solidFill>
-            <a:srgbClr val="0B0F19"/>
+            <a:srgbClr val="FAF8F5"/>
           </a:solidFill>
           <a:ln>
             <a:noFill/>
@@ -8594,7 +8753,7 @@
         <p:spPr>
           <a:xfrm>
             <a:off x="731520" y="365760"/>
-            <a:ext cx="10698480" cy="365760"/>
+            <a:ext cx="10698480" cy="320040"/>
           </a:xfrm>
           <a:prstGeom prst="rect">
             <a:avLst/>
@@ -8610,7 +8769,7 @@
             <a:pPr>
               <a:defRPr sz="1000" b="1">
                 <a:solidFill>
-                  <a:srgbClr val="10B981"/>
+                  <a:srgbClr val="225E42"/>
                 </a:solidFill>
                 <a:latin typeface="Helvetica"/>
               </a:defRPr>
@@ -8646,9 +8805,9 @@
             <a:pPr>
               <a:defRPr sz="2400" b="1">
                 <a:solidFill>
-                  <a:srgbClr val="FFFFFF"/>
-                </a:solidFill>
-                <a:latin typeface="Helvetica"/>
+                  <a:srgbClr val="171717"/>
+                </a:solidFill>
+                <a:latin typeface="Georgia"/>
               </a:defRPr>
             </a:pPr>
             <a:r>
@@ -8657,9 +8816,9 @@
           </a:p>
           <a:p>
             <a:pPr>
-              <a:defRPr sz="1300">
-                <a:solidFill>
-                  <a:srgbClr val="94A3B8"/>
+              <a:defRPr sz="1200">
+                <a:solidFill>
+                  <a:srgbClr val="66625C"/>
                 </a:solidFill>
                 <a:latin typeface="Helvetica"/>
               </a:defRPr>
@@ -8685,11 +8844,11 @@
             <a:avLst/>
           </a:prstGeom>
           <a:solidFill>
-            <a:srgbClr val="131C2E"/>
+            <a:srgbClr val="FFFFFF"/>
           </a:solidFill>
           <a:ln w="12700">
             <a:solidFill>
-              <a:srgbClr val="1E293B"/>
+              <a:srgbClr val="E4E0D8"/>
             </a:solidFill>
           </a:ln>
         </p:spPr>
@@ -8714,8 +8873,9 @@
             <a:pPr algn="ctr">
               <a:defRPr sz="2800" b="1">
                 <a:solidFill>
-                  <a:srgbClr val="10B981"/>
-                </a:solidFill>
+                  <a:srgbClr val="225E42"/>
+                </a:solidFill>
+                <a:latin typeface="Georgia"/>
               </a:defRPr>
             </a:pPr>
             <a:r>
@@ -8727,8 +8887,9 @@
             <a:pPr>
               <a:defRPr sz="1600" b="1">
                 <a:solidFill>
-                  <a:srgbClr val="FFFFFF"/>
-                </a:solidFill>
+                  <a:srgbClr val="171717"/>
+                </a:solidFill>
+                <a:latin typeface="Georgia"/>
               </a:defRPr>
             </a:pPr>
             <a:r>
@@ -8740,8 +8901,9 @@
             <a:pPr>
               <a:defRPr sz="1100">
                 <a:solidFill>
-                  <a:srgbClr val="94A3B8"/>
-                </a:solidFill>
+                  <a:srgbClr val="66625C"/>
+                </a:solidFill>
+                <a:latin typeface="Helvetica"/>
               </a:defRPr>
             </a:pPr>
             <a:r>
@@ -8753,8 +8915,9 @@
             <a:pPr>
               <a:defRPr sz="1100" b="1">
                 <a:solidFill>
-                  <a:srgbClr val="10B981"/>
-                </a:solidFill>
+                  <a:srgbClr val="225E42"/>
+                </a:solidFill>
+                <a:latin typeface="Helvetica"/>
               </a:defRPr>
             </a:pPr>
             <a:r>
@@ -8778,11 +8941,11 @@
             <a:avLst/>
           </a:prstGeom>
           <a:solidFill>
-            <a:srgbClr val="131C2E"/>
+            <a:srgbClr val="FFFFFF"/>
           </a:solidFill>
           <a:ln w="12700">
             <a:solidFill>
-              <a:srgbClr val="14B8A6"/>
+              <a:srgbClr val="225E42"/>
             </a:solidFill>
           </a:ln>
         </p:spPr>
@@ -8807,8 +8970,9 @@
             <a:pPr algn="ctr">
               <a:defRPr sz="2800" b="1">
                 <a:solidFill>
-                  <a:srgbClr val="14B8A6"/>
-                </a:solidFill>
+                  <a:srgbClr val="225E42"/>
+                </a:solidFill>
+                <a:latin typeface="Georgia"/>
               </a:defRPr>
             </a:pPr>
             <a:r>
@@ -8820,8 +8984,9 @@
             <a:pPr>
               <a:defRPr sz="1600" b="1">
                 <a:solidFill>
-                  <a:srgbClr val="FFFFFF"/>
-                </a:solidFill>
+                  <a:srgbClr val="171717"/>
+                </a:solidFill>
+                <a:latin typeface="Georgia"/>
               </a:defRPr>
             </a:pPr>
             <a:r>
@@ -8833,8 +8998,9 @@
             <a:pPr>
               <a:defRPr sz="1100">
                 <a:solidFill>
-                  <a:srgbClr val="94A3B8"/>
-                </a:solidFill>
+                  <a:srgbClr val="66625C"/>
+                </a:solidFill>
+                <a:latin typeface="Helvetica"/>
               </a:defRPr>
             </a:pPr>
             <a:r>
@@ -8846,8 +9012,9 @@
             <a:pPr>
               <a:defRPr sz="1100" b="1">
                 <a:solidFill>
-                  <a:srgbClr val="14B8A6"/>
-                </a:solidFill>
+                  <a:srgbClr val="225E42"/>
+                </a:solidFill>
+                <a:latin typeface="Helvetica"/>
               </a:defRPr>
             </a:pPr>
             <a:r>
@@ -8871,11 +9038,11 @@
             <a:avLst/>
           </a:prstGeom>
           <a:solidFill>
-            <a:srgbClr val="131C2E"/>
+            <a:srgbClr val="FFFFFF"/>
           </a:solidFill>
           <a:ln w="12700">
             <a:solidFill>
-              <a:srgbClr val="06B6D4"/>
+              <a:srgbClr val="A65A24"/>
             </a:solidFill>
           </a:ln>
         </p:spPr>
@@ -8900,8 +9067,9 @@
             <a:pPr algn="ctr">
               <a:defRPr sz="2800" b="1">
                 <a:solidFill>
-                  <a:srgbClr val="06B6D4"/>
-                </a:solidFill>
+                  <a:srgbClr val="A65A24"/>
+                </a:solidFill>
+                <a:latin typeface="Georgia"/>
               </a:defRPr>
             </a:pPr>
             <a:r>
@@ -8913,8 +9081,9 @@
             <a:pPr>
               <a:defRPr sz="1600" b="1">
                 <a:solidFill>
-                  <a:srgbClr val="FFFFFF"/>
-                </a:solidFill>
+                  <a:srgbClr val="171717"/>
+                </a:solidFill>
+                <a:latin typeface="Georgia"/>
               </a:defRPr>
             </a:pPr>
             <a:r>
@@ -8926,8 +9095,9 @@
             <a:pPr>
               <a:defRPr sz="1100">
                 <a:solidFill>
-                  <a:srgbClr val="94A3B8"/>
-                </a:solidFill>
+                  <a:srgbClr val="66625C"/>
+                </a:solidFill>
+                <a:latin typeface="Helvetica"/>
               </a:defRPr>
             </a:pPr>
             <a:r>
@@ -8939,8 +9109,9 @@
             <a:pPr>
               <a:defRPr sz="1100" b="1">
                 <a:solidFill>
-                  <a:srgbClr val="06B6D4"/>
-                </a:solidFill>
+                  <a:srgbClr val="A65A24"/>
+                </a:solidFill>
+                <a:latin typeface="Helvetica"/>
               </a:defRPr>
             </a:pPr>
             <a:r>
@@ -8964,11 +9135,11 @@
             <a:avLst/>
           </a:prstGeom>
           <a:solidFill>
-            <a:srgbClr val="131C2E"/>
+            <a:srgbClr val="F3F0EA"/>
           </a:solidFill>
           <a:ln w="12700">
             <a:solidFill>
-              <a:srgbClr val="1E293B"/>
+              <a:srgbClr val="E4E0D8"/>
             </a:solidFill>
           </a:ln>
         </p:spPr>
@@ -8993,8 +9164,9 @@
             <a:pPr algn="ctr">
               <a:defRPr sz="1100" b="1">
                 <a:solidFill>
-                  <a:srgbClr val="10B981"/>
-                </a:solidFill>
+                  <a:srgbClr val="171717"/>
+                </a:solidFill>
+                <a:latin typeface="Helvetica"/>
               </a:defRPr>
             </a:pPr>
             <a:r>
@@ -9036,7 +9208,7 @@
             <a:avLst/>
           </a:prstGeom>
           <a:solidFill>
-            <a:srgbClr val="0B0F19"/>
+            <a:srgbClr val="FAF8F5"/>
           </a:solidFill>
           <a:ln>
             <a:noFill/>
@@ -9073,7 +9245,7 @@
         <p:spPr>
           <a:xfrm>
             <a:off x="731520" y="365760"/>
-            <a:ext cx="10698480" cy="365760"/>
+            <a:ext cx="10698480" cy="320040"/>
           </a:xfrm>
           <a:prstGeom prst="rect">
             <a:avLst/>
@@ -9089,7 +9261,7 @@
             <a:pPr>
               <a:defRPr sz="1000" b="1">
                 <a:solidFill>
-                  <a:srgbClr val="10B981"/>
+                  <a:srgbClr val="225E42"/>
                 </a:solidFill>
                 <a:latin typeface="Helvetica"/>
               </a:defRPr>
@@ -9125,9 +9297,9 @@
             <a:pPr>
               <a:defRPr sz="2400" b="1">
                 <a:solidFill>
-                  <a:srgbClr val="FFFFFF"/>
-                </a:solidFill>
-                <a:latin typeface="Helvetica"/>
+                  <a:srgbClr val="171717"/>
+                </a:solidFill>
+                <a:latin typeface="Georgia"/>
               </a:defRPr>
             </a:pPr>
             <a:r>
@@ -9136,9 +9308,9 @@
           </a:p>
           <a:p>
             <a:pPr>
-              <a:defRPr sz="1300">
-                <a:solidFill>
-                  <a:srgbClr val="94A3B8"/>
+              <a:defRPr sz="1200">
+                <a:solidFill>
+                  <a:srgbClr val="66625C"/>
                 </a:solidFill>
                 <a:latin typeface="Helvetica"/>
               </a:defRPr>
@@ -9164,11 +9336,11 @@
             <a:avLst/>
           </a:prstGeom>
           <a:solidFill>
-            <a:srgbClr val="131C2E"/>
+            <a:srgbClr val="FFFFFF"/>
           </a:solidFill>
           <a:ln w="12700">
             <a:solidFill>
-              <a:srgbClr val="EF4444"/>
+              <a:srgbClr val="B91C1C"/>
             </a:solidFill>
           </a:ln>
         </p:spPr>
@@ -9193,8 +9365,9 @@
             <a:pPr algn="ctr">
               <a:defRPr sz="1300" b="1">
                 <a:solidFill>
-                  <a:srgbClr val="EF4444"/>
-                </a:solidFill>
+                  <a:srgbClr val="B91C1C"/>
+                </a:solidFill>
+                <a:latin typeface="Helvetica"/>
               </a:defRPr>
             </a:pPr>
             <a:r>
@@ -9206,8 +9379,9 @@
             <a:pPr>
               <a:defRPr sz="1200">
                 <a:solidFill>
-                  <a:srgbClr val="FFFFFF"/>
-                </a:solidFill>
+                  <a:srgbClr val="171717"/>
+                </a:solidFill>
+                <a:latin typeface="Helvetica"/>
               </a:defRPr>
             </a:pPr>
             <a:r>
@@ -9226,10 +9400,11 @@
           </a:p>
           <a:p>
             <a:pPr>
-              <a:defRPr sz="1600" b="1">
-                <a:solidFill>
-                  <a:srgbClr val="EF4444"/>
-                </a:solidFill>
+              <a:defRPr sz="1800" b="1">
+                <a:solidFill>
+                  <a:srgbClr val="B91C1C"/>
+                </a:solidFill>
+                <a:latin typeface="Georgia"/>
               </a:defRPr>
             </a:pPr>
             <a:r>
@@ -9242,8 +9417,9 @@
             <a:pPr>
               <a:defRPr sz="1100">
                 <a:solidFill>
-                  <a:srgbClr val="94A3B8"/>
-                </a:solidFill>
+                  <a:srgbClr val="66625C"/>
+                </a:solidFill>
+                <a:latin typeface="Helvetica"/>
               </a:defRPr>
             </a:pPr>
             <a:r>
@@ -9267,11 +9443,11 @@
             <a:avLst/>
           </a:prstGeom>
           <a:solidFill>
-            <a:srgbClr val="131C2E"/>
+            <a:srgbClr val="F1F7F3"/>
           </a:solidFill>
           <a:ln w="12700">
             <a:solidFill>
-              <a:srgbClr val="10B981"/>
+              <a:srgbClr val="225E42"/>
             </a:solidFill>
           </a:ln>
         </p:spPr>
@@ -9296,8 +9472,9 @@
             <a:pPr algn="ctr">
               <a:defRPr sz="1300" b="1">
                 <a:solidFill>
-                  <a:srgbClr val="10B981"/>
-                </a:solidFill>
+                  <a:srgbClr val="225E42"/>
+                </a:solidFill>
+                <a:latin typeface="Helvetica"/>
               </a:defRPr>
             </a:pPr>
             <a:r>
@@ -9309,8 +9486,9 @@
             <a:pPr>
               <a:defRPr sz="1200">
                 <a:solidFill>
-                  <a:srgbClr val="10B981"/>
-                </a:solidFill>
+                  <a:srgbClr val="225E42"/>
+                </a:solidFill>
+                <a:latin typeface="Helvetica"/>
               </a:defRPr>
             </a:pPr>
             <a:r>
@@ -9329,10 +9507,11 @@
           </a:p>
           <a:p>
             <a:pPr>
-              <a:defRPr sz="1600" b="1">
-                <a:solidFill>
-                  <a:srgbClr val="10B981"/>
-                </a:solidFill>
+              <a:defRPr sz="1800" b="1">
+                <a:solidFill>
+                  <a:srgbClr val="225E42"/>
+                </a:solidFill>
+                <a:latin typeface="Georgia"/>
               </a:defRPr>
             </a:pPr>
             <a:r>
@@ -9343,10 +9522,11 @@
           </a:p>
           <a:p>
             <a:pPr>
-              <a:defRPr sz="1100">
-                <a:solidFill>
-                  <a:srgbClr val="FFFFFF"/>
-                </a:solidFill>
+              <a:defRPr sz="1100" b="1">
+                <a:solidFill>
+                  <a:srgbClr val="171717"/>
+                </a:solidFill>
+                <a:latin typeface="Helvetica"/>
               </a:defRPr>
             </a:pPr>
             <a:r>
@@ -9388,7 +9568,7 @@
             <a:avLst/>
           </a:prstGeom>
           <a:solidFill>
-            <a:srgbClr val="0B0F19"/>
+            <a:srgbClr val="FAF8F5"/>
           </a:solidFill>
           <a:ln>
             <a:noFill/>
@@ -9425,7 +9605,7 @@
         <p:spPr>
           <a:xfrm>
             <a:off x="731520" y="365760"/>
-            <a:ext cx="10698480" cy="365760"/>
+            <a:ext cx="10698480" cy="320040"/>
           </a:xfrm>
           <a:prstGeom prst="rect">
             <a:avLst/>
@@ -9441,7 +9621,7 @@
             <a:pPr>
               <a:defRPr sz="1000" b="1">
                 <a:solidFill>
-                  <a:srgbClr val="10B981"/>
+                  <a:srgbClr val="225E42"/>
                 </a:solidFill>
                 <a:latin typeface="Helvetica"/>
               </a:defRPr>
@@ -9477,9 +9657,9 @@
             <a:pPr>
               <a:defRPr sz="2400" b="1">
                 <a:solidFill>
-                  <a:srgbClr val="FFFFFF"/>
-                </a:solidFill>
-                <a:latin typeface="Helvetica"/>
+                  <a:srgbClr val="171717"/>
+                </a:solidFill>
+                <a:latin typeface="Georgia"/>
               </a:defRPr>
             </a:pPr>
             <a:r>
@@ -9488,9 +9668,9 @@
           </a:p>
           <a:p>
             <a:pPr>
-              <a:defRPr sz="1300">
-                <a:solidFill>
-                  <a:srgbClr val="94A3B8"/>
+              <a:defRPr sz="1200">
+                <a:solidFill>
+                  <a:srgbClr val="66625C"/>
                 </a:solidFill>
                 <a:latin typeface="Helvetica"/>
               </a:defRPr>
@@ -9516,11 +9696,11 @@
             <a:avLst/>
           </a:prstGeom>
           <a:solidFill>
-            <a:srgbClr val="131C2E"/>
+            <a:srgbClr val="FFFFFF"/>
           </a:solidFill>
           <a:ln w="12700">
             <a:solidFill>
-              <a:srgbClr val="1E293B"/>
+              <a:srgbClr val="E4E0D8"/>
             </a:solidFill>
           </a:ln>
         </p:spPr>
@@ -9545,8 +9725,9 @@
             <a:pPr algn="ctr">
               <a:defRPr sz="1100" b="1">
                 <a:solidFill>
-                  <a:srgbClr val="FFFFFF"/>
-                </a:solidFill>
+                  <a:srgbClr val="171717"/>
+                </a:solidFill>
+                <a:latin typeface="Helvetica"/>
               </a:defRPr>
             </a:pPr>
             <a:r>
@@ -9558,8 +9739,9 @@
             <a:pPr>
               <a:defRPr sz="1400" b="1">
                 <a:solidFill>
-                  <a:srgbClr val="FFFFFF"/>
-                </a:solidFill>
+                  <a:srgbClr val="171717"/>
+                </a:solidFill>
+                <a:latin typeface="Georgia"/>
               </a:defRPr>
             </a:pPr>
             <a:r>
@@ -9572,8 +9754,9 @@
             <a:pPr>
               <a:defRPr sz="1050">
                 <a:solidFill>
-                  <a:srgbClr val="94A3B8"/>
-                </a:solidFill>
+                  <a:srgbClr val="66625C"/>
+                </a:solidFill>
+                <a:latin typeface="Helvetica"/>
               </a:defRPr>
             </a:pPr>
             <a:r>
@@ -9586,8 +9769,9 @@
             <a:pPr>
               <a:defRPr sz="1000" b="1">
                 <a:solidFill>
-                  <a:srgbClr val="FFFFFF"/>
-                </a:solidFill>
+                  <a:srgbClr val="171717"/>
+                </a:solidFill>
+                <a:latin typeface="Helvetica"/>
               </a:defRPr>
             </a:pPr>
             <a:r>
@@ -9611,11 +9795,11 @@
             <a:avLst/>
           </a:prstGeom>
           <a:solidFill>
-            <a:srgbClr val="131C2E"/>
+            <a:srgbClr val="FFFFFF"/>
           </a:solidFill>
           <a:ln w="12700">
             <a:solidFill>
-              <a:srgbClr val="14B8A6"/>
+              <a:srgbClr val="225E42"/>
             </a:solidFill>
           </a:ln>
         </p:spPr>
@@ -9640,8 +9824,9 @@
             <a:pPr algn="ctr">
               <a:defRPr sz="1100" b="1">
                 <a:solidFill>
-                  <a:srgbClr val="14B8A6"/>
-                </a:solidFill>
+                  <a:srgbClr val="225E42"/>
+                </a:solidFill>
+                <a:latin typeface="Helvetica"/>
               </a:defRPr>
             </a:pPr>
             <a:r>
@@ -9653,8 +9838,9 @@
             <a:pPr>
               <a:defRPr sz="1400" b="1">
                 <a:solidFill>
-                  <a:srgbClr val="FFFFFF"/>
-                </a:solidFill>
+                  <a:srgbClr val="171717"/>
+                </a:solidFill>
+                <a:latin typeface="Georgia"/>
               </a:defRPr>
             </a:pPr>
             <a:r>
@@ -9667,8 +9853,9 @@
             <a:pPr>
               <a:defRPr sz="1050">
                 <a:solidFill>
-                  <a:srgbClr val="94A3B8"/>
-                </a:solidFill>
+                  <a:srgbClr val="66625C"/>
+                </a:solidFill>
+                <a:latin typeface="Helvetica"/>
               </a:defRPr>
             </a:pPr>
             <a:r>
@@ -9681,8 +9868,9 @@
             <a:pPr>
               <a:defRPr sz="1000" b="1">
                 <a:solidFill>
-                  <a:srgbClr val="14B8A6"/>
-                </a:solidFill>
+                  <a:srgbClr val="225E42"/>
+                </a:solidFill>
+                <a:latin typeface="Helvetica"/>
               </a:defRPr>
             </a:pPr>
             <a:r>
@@ -9706,11 +9894,11 @@
             <a:avLst/>
           </a:prstGeom>
           <a:solidFill>
-            <a:srgbClr val="131C2E"/>
+            <a:srgbClr val="FFFFFF"/>
           </a:solidFill>
           <a:ln w="12700">
             <a:solidFill>
-              <a:srgbClr val="06B6D4"/>
+              <a:srgbClr val="A65A24"/>
             </a:solidFill>
           </a:ln>
         </p:spPr>
@@ -9735,8 +9923,9 @@
             <a:pPr algn="ctr">
               <a:defRPr sz="1100" b="1">
                 <a:solidFill>
-                  <a:srgbClr val="06B6D4"/>
-                </a:solidFill>
+                  <a:srgbClr val="A65A24"/>
+                </a:solidFill>
+                <a:latin typeface="Helvetica"/>
               </a:defRPr>
             </a:pPr>
             <a:r>
@@ -9748,8 +9937,9 @@
             <a:pPr>
               <a:defRPr sz="1400" b="1">
                 <a:solidFill>
-                  <a:srgbClr val="FFFFFF"/>
-                </a:solidFill>
+                  <a:srgbClr val="171717"/>
+                </a:solidFill>
+                <a:latin typeface="Georgia"/>
               </a:defRPr>
             </a:pPr>
             <a:r>
@@ -9762,8 +9952,9 @@
             <a:pPr>
               <a:defRPr sz="1050">
                 <a:solidFill>
-                  <a:srgbClr val="94A3B8"/>
-                </a:solidFill>
+                  <a:srgbClr val="66625C"/>
+                </a:solidFill>
+                <a:latin typeface="Helvetica"/>
               </a:defRPr>
             </a:pPr>
             <a:r>
@@ -9776,8 +9967,9 @@
             <a:pPr>
               <a:defRPr sz="1000" b="1">
                 <a:solidFill>
-                  <a:srgbClr val="06B6D4"/>
-                </a:solidFill>
+                  <a:srgbClr val="A65A24"/>
+                </a:solidFill>
+                <a:latin typeface="Helvetica"/>
               </a:defRPr>
             </a:pPr>
             <a:r>
@@ -9801,11 +9993,11 @@
             <a:avLst/>
           </a:prstGeom>
           <a:solidFill>
-            <a:srgbClr val="131C2E"/>
+            <a:srgbClr val="FFFFFF"/>
           </a:solidFill>
           <a:ln w="12700">
             <a:solidFill>
-              <a:srgbClr val="10B981"/>
+              <a:srgbClr val="225E42"/>
             </a:solidFill>
           </a:ln>
         </p:spPr>
@@ -9830,8 +10022,9 @@
             <a:pPr algn="ctr">
               <a:defRPr sz="1100" b="1">
                 <a:solidFill>
-                  <a:srgbClr val="10B981"/>
-                </a:solidFill>
+                  <a:srgbClr val="225E42"/>
+                </a:solidFill>
+                <a:latin typeface="Helvetica"/>
               </a:defRPr>
             </a:pPr>
             <a:r>
@@ -9843,8 +10036,9 @@
             <a:pPr>
               <a:defRPr sz="1400" b="1">
                 <a:solidFill>
-                  <a:srgbClr val="FFFFFF"/>
-                </a:solidFill>
+                  <a:srgbClr val="171717"/>
+                </a:solidFill>
+                <a:latin typeface="Georgia"/>
               </a:defRPr>
             </a:pPr>
             <a:r>
@@ -9857,8 +10051,9 @@
             <a:pPr>
               <a:defRPr sz="1050">
                 <a:solidFill>
-                  <a:srgbClr val="94A3B8"/>
-                </a:solidFill>
+                  <a:srgbClr val="66625C"/>
+                </a:solidFill>
+                <a:latin typeface="Helvetica"/>
               </a:defRPr>
             </a:pPr>
             <a:r>
@@ -9871,8 +10066,9 @@
             <a:pPr>
               <a:defRPr sz="1000" b="1">
                 <a:solidFill>
-                  <a:srgbClr val="10B981"/>
-                </a:solidFill>
+                  <a:srgbClr val="225E42"/>
+                </a:solidFill>
+                <a:latin typeface="Helvetica"/>
               </a:defRPr>
             </a:pPr>
             <a:r>
@@ -9896,11 +10092,11 @@
             <a:avLst/>
           </a:prstGeom>
           <a:solidFill>
-            <a:srgbClr val="131C2E"/>
+            <a:srgbClr val="F3F0EA"/>
           </a:solidFill>
           <a:ln w="12700">
             <a:solidFill>
-              <a:srgbClr val="1E293B"/>
+              <a:srgbClr val="E4E0D8"/>
             </a:solidFill>
           </a:ln>
         </p:spPr>
@@ -9925,8 +10121,9 @@
             <a:pPr algn="ctr">
               <a:defRPr sz="1100" b="1">
                 <a:solidFill>
-                  <a:srgbClr val="10B981"/>
-                </a:solidFill>
+                  <a:srgbClr val="225E42"/>
+                </a:solidFill>
+                <a:latin typeface="Helvetica"/>
               </a:defRPr>
             </a:pPr>
             <a:r>
@@ -9968,7 +10165,7 @@
             <a:avLst/>
           </a:prstGeom>
           <a:solidFill>
-            <a:srgbClr val="0B0F19"/>
+            <a:srgbClr val="FAF8F5"/>
           </a:solidFill>
           <a:ln>
             <a:noFill/>
@@ -10005,7 +10202,7 @@
         <p:spPr>
           <a:xfrm>
             <a:off x="731520" y="365760"/>
-            <a:ext cx="10698480" cy="365760"/>
+            <a:ext cx="10698480" cy="320040"/>
           </a:xfrm>
           <a:prstGeom prst="rect">
             <a:avLst/>
@@ -10021,7 +10218,7 @@
             <a:pPr>
               <a:defRPr sz="1000" b="1">
                 <a:solidFill>
-                  <a:srgbClr val="10B981"/>
+                  <a:srgbClr val="225E42"/>
                 </a:solidFill>
                 <a:latin typeface="Helvetica"/>
               </a:defRPr>
@@ -10057,9 +10254,9 @@
             <a:pPr>
               <a:defRPr sz="2400" b="1">
                 <a:solidFill>
-                  <a:srgbClr val="FFFFFF"/>
-                </a:solidFill>
-                <a:latin typeface="Helvetica"/>
+                  <a:srgbClr val="171717"/>
+                </a:solidFill>
+                <a:latin typeface="Georgia"/>
               </a:defRPr>
             </a:pPr>
             <a:r>
@@ -10068,9 +10265,9 @@
           </a:p>
           <a:p>
             <a:pPr>
-              <a:defRPr sz="1300">
-                <a:solidFill>
-                  <a:srgbClr val="94A3B8"/>
+              <a:defRPr sz="1200">
+                <a:solidFill>
+                  <a:srgbClr val="66625C"/>
                 </a:solidFill>
                 <a:latin typeface="Helvetica"/>
               </a:defRPr>
@@ -10096,11 +10293,11 @@
             <a:avLst/>
           </a:prstGeom>
           <a:solidFill>
-            <a:srgbClr val="131C2E"/>
+            <a:srgbClr val="FFFFFF"/>
           </a:solidFill>
           <a:ln w="12700">
             <a:solidFill>
-              <a:srgbClr val="1E293B"/>
+              <a:srgbClr val="E4E0D8"/>
             </a:solidFill>
           </a:ln>
         </p:spPr>
@@ -10123,10 +10320,11 @@
           <a:lstStyle/>
           <a:p>
             <a:pPr algn="ctr">
-              <a:defRPr sz="1200" b="1">
-                <a:solidFill>
-                  <a:srgbClr val="14B8A6"/>
-                </a:solidFill>
+              <a:defRPr sz="1100" b="1">
+                <a:solidFill>
+                  <a:srgbClr val="66625C"/>
+                </a:solidFill>
+                <a:latin typeface="Helvetica"/>
               </a:defRPr>
             </a:pPr>
             <a:r>
@@ -10138,8 +10336,9 @@
             <a:pPr>
               <a:defRPr sz="1800" b="1">
                 <a:solidFill>
-                  <a:srgbClr val="FFFFFF"/>
-                </a:solidFill>
+                  <a:srgbClr val="171717"/>
+                </a:solidFill>
+                <a:latin typeface="Georgia"/>
               </a:defRPr>
             </a:pPr>
             <a:r>
@@ -10149,10 +10348,11 @@
           </a:p>
           <a:p>
             <a:pPr>
-              <a:defRPr sz="1200">
-                <a:solidFill>
-                  <a:srgbClr val="94A3B8"/>
-                </a:solidFill>
+              <a:defRPr sz="1150">
+                <a:solidFill>
+                  <a:srgbClr val="66625C"/>
+                </a:solidFill>
+                <a:latin typeface="Helvetica"/>
               </a:defRPr>
             </a:pPr>
             <a:r>
@@ -10163,10 +10363,11 @@
           </a:p>
           <a:p>
             <a:pPr>
-              <a:defRPr sz="1200" b="1">
-                <a:solidFill>
-                  <a:srgbClr val="FFFFFF"/>
-                </a:solidFill>
+              <a:defRPr sz="1150" b="1">
+                <a:solidFill>
+                  <a:srgbClr val="171717"/>
+                </a:solidFill>
+                <a:latin typeface="Helvetica"/>
               </a:defRPr>
             </a:pPr>
             <a:r>
@@ -10190,11 +10391,11 @@
             <a:avLst/>
           </a:prstGeom>
           <a:solidFill>
-            <a:srgbClr val="131C2E"/>
+            <a:srgbClr val="FFFFFF"/>
           </a:solidFill>
           <a:ln w="12700">
             <a:solidFill>
-              <a:srgbClr val="10B981"/>
+              <a:srgbClr val="225E42"/>
             </a:solidFill>
           </a:ln>
         </p:spPr>
@@ -10217,10 +10418,11 @@
           <a:lstStyle/>
           <a:p>
             <a:pPr algn="ctr">
-              <a:defRPr sz="1200" b="1">
-                <a:solidFill>
-                  <a:srgbClr val="10B981"/>
-                </a:solidFill>
+              <a:defRPr sz="1100" b="1">
+                <a:solidFill>
+                  <a:srgbClr val="225E42"/>
+                </a:solidFill>
+                <a:latin typeface="Helvetica"/>
               </a:defRPr>
             </a:pPr>
             <a:r>
@@ -10232,8 +10434,9 @@
             <a:pPr>
               <a:defRPr sz="1800" b="1">
                 <a:solidFill>
-                  <a:srgbClr val="FFFFFF"/>
-                </a:solidFill>
+                  <a:srgbClr val="171717"/>
+                </a:solidFill>
+                <a:latin typeface="Georgia"/>
               </a:defRPr>
             </a:pPr>
             <a:r>
@@ -10243,14 +10446,15 @@
           </a:p>
           <a:p>
             <a:pPr>
-              <a:defRPr sz="1200">
-                <a:solidFill>
-                  <a:srgbClr val="94A3B8"/>
-                </a:solidFill>
-              </a:defRPr>
-            </a:pPr>
-            <a:r>
-              <a:t>Enterprise buyers (e.g. Skanska, Peab) currently earn ~2.5% in commercial bank deposits. By funding early payouts to their own verified suppliers, the Anchor earns a 1% discount on 15-day turnover:</a:t>
+              <a:defRPr sz="1150">
+                <a:solidFill>
+                  <a:srgbClr val="66625C"/>
+                </a:solidFill>
+                <a:latin typeface="Helvetica"/>
+              </a:defRPr>
+            </a:pPr>
+            <a:r>
+              <a:t>Enterprise buyers (e.g. Skanska, Peab, funded startups) currently earn ~2.5% in commercial bank deposits. By funding early payouts to their own verified suppliers, the Anchor earns a 1% discount on 15-day turnover:</a:t>
             </a:r>
             <a:br/>
             <a:br/>
@@ -10259,8 +10463,9 @@
             <a:pPr>
               <a:defRPr sz="1400" b="1">
                 <a:solidFill>
-                  <a:srgbClr val="10B981"/>
-                </a:solidFill>
+                  <a:srgbClr val="225E42"/>
+                </a:solidFill>
+                <a:latin typeface="Georgia"/>
               </a:defRPr>
             </a:pPr>
             <a:r>
@@ -10284,11 +10489,11 @@
             <a:avLst/>
           </a:prstGeom>
           <a:solidFill>
-            <a:srgbClr val="131C2E"/>
+            <a:srgbClr val="F3F0EA"/>
           </a:solidFill>
           <a:ln w="12700">
             <a:solidFill>
-              <a:srgbClr val="1E293B"/>
+              <a:srgbClr val="E4E0D8"/>
             </a:solidFill>
           </a:ln>
         </p:spPr>
@@ -10313,8 +10518,9 @@
             <a:pPr algn="ctr">
               <a:defRPr sz="1100" b="1">
                 <a:solidFill>
-                  <a:srgbClr val="10B981"/>
-                </a:solidFill>
+                  <a:srgbClr val="171717"/>
+                </a:solidFill>
+                <a:latin typeface="Helvetica"/>
               </a:defRPr>
             </a:pPr>
             <a:r>
@@ -10356,7 +10562,7 @@
             <a:avLst/>
           </a:prstGeom>
           <a:solidFill>
-            <a:srgbClr val="0B0F19"/>
+            <a:srgbClr val="FAF8F5"/>
           </a:solidFill>
           <a:ln>
             <a:noFill/>
@@ -10393,7 +10599,7 @@
         <p:spPr>
           <a:xfrm>
             <a:off x="731520" y="365760"/>
-            <a:ext cx="10698480" cy="365760"/>
+            <a:ext cx="10698480" cy="320040"/>
           </a:xfrm>
           <a:prstGeom prst="rect">
             <a:avLst/>
@@ -10409,7 +10615,7 @@
             <a:pPr>
               <a:defRPr sz="1000" b="1">
                 <a:solidFill>
-                  <a:srgbClr val="10B981"/>
+                  <a:srgbClr val="225E42"/>
                 </a:solidFill>
                 <a:latin typeface="Helvetica"/>
               </a:defRPr>
@@ -10445,9 +10651,9 @@
             <a:pPr>
               <a:defRPr sz="2400" b="1">
                 <a:solidFill>
-                  <a:srgbClr val="FFFFFF"/>
-                </a:solidFill>
-                <a:latin typeface="Helvetica"/>
+                  <a:srgbClr val="171717"/>
+                </a:solidFill>
+                <a:latin typeface="Georgia"/>
               </a:defRPr>
             </a:pPr>
             <a:r>
@@ -10456,9 +10662,9 @@
           </a:p>
           <a:p>
             <a:pPr>
-              <a:defRPr sz="1300">
-                <a:solidFill>
-                  <a:srgbClr val="94A3B8"/>
+              <a:defRPr sz="1200">
+                <a:solidFill>
+                  <a:srgbClr val="66625C"/>
                 </a:solidFill>
                 <a:latin typeface="Helvetica"/>
               </a:defRPr>
@@ -10484,11 +10690,11 @@
             <a:avLst/>
           </a:prstGeom>
           <a:solidFill>
-            <a:srgbClr val="131C2E"/>
+            <a:srgbClr val="FFFFFF"/>
           </a:solidFill>
           <a:ln w="12700">
             <a:solidFill>
-              <a:srgbClr val="1E293B"/>
+              <a:srgbClr val="E4E0D8"/>
             </a:solidFill>
           </a:ln>
         </p:spPr>
@@ -10513,8 +10719,9 @@
             <a:pPr algn="ctr">
               <a:defRPr sz="1300" b="1">
                 <a:solidFill>
-                  <a:srgbClr val="94A3B8"/>
-                </a:solidFill>
+                  <a:srgbClr val="171717"/>
+                </a:solidFill>
+                <a:latin typeface="Helvetica"/>
               </a:defRPr>
             </a:pPr>
             <a:r>
@@ -10526,8 +10733,9 @@
             <a:pPr>
               <a:defRPr sz="1100">
                 <a:solidFill>
-                  <a:srgbClr val="FFFFFF"/>
-                </a:solidFill>
+                  <a:srgbClr val="171717"/>
+                </a:solidFill>
+                <a:latin typeface="Helvetica"/>
               </a:defRPr>
             </a:pPr>
             <a:r>
@@ -10551,11 +10759,11 @@
             <a:avLst/>
           </a:prstGeom>
           <a:solidFill>
-            <a:srgbClr val="131C2E"/>
+            <a:srgbClr val="FFFFFF"/>
           </a:solidFill>
           <a:ln w="12700">
             <a:solidFill>
-              <a:srgbClr val="10B981"/>
+              <a:srgbClr val="225E42"/>
             </a:solidFill>
           </a:ln>
         </p:spPr>
@@ -10580,8 +10788,9 @@
             <a:pPr algn="ctr">
               <a:defRPr sz="1300" b="1">
                 <a:solidFill>
-                  <a:srgbClr val="10B981"/>
-                </a:solidFill>
+                  <a:srgbClr val="225E42"/>
+                </a:solidFill>
+                <a:latin typeface="Helvetica"/>
               </a:defRPr>
             </a:pPr>
             <a:r>
@@ -10593,8 +10802,9 @@
             <a:pPr>
               <a:defRPr sz="1100">
                 <a:solidFill>
-                  <a:srgbClr val="FFFFFF"/>
-                </a:solidFill>
+                  <a:srgbClr val="171717"/>
+                </a:solidFill>
+                <a:latin typeface="Helvetica"/>
               </a:defRPr>
             </a:pPr>
             <a:r>
@@ -10618,11 +10828,11 @@
             <a:avLst/>
           </a:prstGeom>
           <a:solidFill>
-            <a:srgbClr val="131C2E"/>
+            <a:srgbClr val="FFFFFF"/>
           </a:solidFill>
           <a:ln w="12700">
             <a:solidFill>
-              <a:srgbClr val="14B8A6"/>
+              <a:srgbClr val="A65A24"/>
             </a:solidFill>
           </a:ln>
         </p:spPr>
@@ -10647,8 +10857,9 @@
             <a:pPr algn="ctr">
               <a:defRPr sz="1300" b="1">
                 <a:solidFill>
-                  <a:srgbClr val="14B8A6"/>
-                </a:solidFill>
+                  <a:srgbClr val="A65A24"/>
+                </a:solidFill>
+                <a:latin typeface="Helvetica"/>
               </a:defRPr>
             </a:pPr>
             <a:r>
@@ -10660,8 +10871,9 @@
             <a:pPr>
               <a:defRPr sz="1100">
                 <a:solidFill>
-                  <a:srgbClr val="FFFFFF"/>
-                </a:solidFill>
+                  <a:srgbClr val="171717"/>
+                </a:solidFill>
+                <a:latin typeface="Helvetica"/>
               </a:defRPr>
             </a:pPr>
             <a:r>
@@ -10685,11 +10897,11 @@
             <a:avLst/>
           </a:prstGeom>
           <a:solidFill>
-            <a:srgbClr val="131C2E"/>
+            <a:srgbClr val="FFFFFF"/>
           </a:solidFill>
           <a:ln w="12700">
             <a:solidFill>
-              <a:srgbClr val="06B6D4"/>
+              <a:srgbClr val="E4E0D8"/>
             </a:solidFill>
           </a:ln>
         </p:spPr>
@@ -10714,8 +10926,9 @@
             <a:pPr algn="ctr">
               <a:defRPr sz="1300" b="1">
                 <a:solidFill>
-                  <a:srgbClr val="06B6D4"/>
-                </a:solidFill>
+                  <a:srgbClr val="66625C"/>
+                </a:solidFill>
+                <a:latin typeface="Helvetica"/>
               </a:defRPr>
             </a:pPr>
             <a:r>
@@ -10727,8 +10940,9 @@
             <a:pPr>
               <a:defRPr sz="1100">
                 <a:solidFill>
-                  <a:srgbClr val="FFFFFF"/>
-                </a:solidFill>
+                  <a:srgbClr val="171717"/>
+                </a:solidFill>
+                <a:latin typeface="Helvetica"/>
               </a:defRPr>
             </a:pPr>
             <a:r>

</xml_diff>